<commit_message>
Use template-matching Thai fonts in course deck (Chonburi headings, Sarabun body)
Bundle the OFL-licensed font files under claude-course/fonts/ so the deck
renders correctly on the presenting machine.

Co-Authored-By: Claude Fable 5 <noreply@anthropic.com>
Claude-Session: https://claude.ai/code/session_01AxZ4pNCruM5GfLEZYmb7ZS
</commit_message>
<xml_diff>
--- a/claude-course/slides.pptx
+++ b/claude-course/slides.pptx
@@ -2294,9 +2294,9 @@
                 <a:solidFill>
                   <a:srgbClr val="AD3A38"/>
                 </a:solidFill>
-                <a:latin typeface="Tahoma" pitchFamily="34" charset="0"/>
-                <a:ea typeface="Tahoma" pitchFamily="34" charset="-122"/>
-                <a:cs typeface="Tahoma" pitchFamily="34" charset="-120"/>
+                <a:latin typeface="Chonburi" pitchFamily="34" charset="0"/>
+                <a:ea typeface="Chonburi" pitchFamily="34" charset="-122"/>
+                <a:cs typeface="Chonburi" pitchFamily="34" charset="-120"/>
               </a:rPr>
               <a:t>ใช้ AI ทำงานจริง</a:t>
             </a:r>
@@ -2333,9 +2333,9 @@
                 <a:solidFill>
                   <a:srgbClr val="C65E52"/>
                 </a:solidFill>
-                <a:latin typeface="Tahoma" pitchFamily="34" charset="0"/>
-                <a:ea typeface="Tahoma" pitchFamily="34" charset="-122"/>
-                <a:cs typeface="Tahoma" pitchFamily="34" charset="-120"/>
+                <a:latin typeface="Sarabun" pitchFamily="34" charset="0"/>
+                <a:ea typeface="Sarabun" pitchFamily="34" charset="-122"/>
+                <a:cs typeface="Sarabun" pitchFamily="34" charset="-120"/>
               </a:rPr>
               <a:t>คอร์สเร่งรัด 3 ชั่วโมง สำหรับคนไม่มีพื้นฐานมาก่อน</a:t>
             </a:r>
@@ -2394,9 +2394,9 @@
                 <a:solidFill>
                   <a:srgbClr val="2E2420"/>
                 </a:solidFill>
-                <a:latin typeface="Tahoma" pitchFamily="34" charset="0"/>
-                <a:ea typeface="Tahoma" pitchFamily="34" charset="-122"/>
-                <a:cs typeface="Tahoma" pitchFamily="34" charset="-120"/>
+                <a:latin typeface="Sarabun" pitchFamily="34" charset="0"/>
+                <a:ea typeface="Sarabun" pitchFamily="34" charset="-122"/>
+                <a:cs typeface="Sarabun" pitchFamily="34" charset="-120"/>
               </a:rPr>
               <a:t>รู้จักโลก AI</a:t>
             </a:r>
@@ -2455,9 +2455,9 @@
                 <a:solidFill>
                   <a:srgbClr val="2E2420"/>
                 </a:solidFill>
-                <a:latin typeface="Tahoma" pitchFamily="34" charset="0"/>
-                <a:ea typeface="Tahoma" pitchFamily="34" charset="-122"/>
-                <a:cs typeface="Tahoma" pitchFamily="34" charset="-120"/>
+                <a:latin typeface="Sarabun" pitchFamily="34" charset="0"/>
+                <a:ea typeface="Sarabun" pitchFamily="34" charset="-122"/>
+                <a:cs typeface="Sarabun" pitchFamily="34" charset="-120"/>
               </a:rPr>
               <a:t>Cowork ทำงานกับไฟล์</a:t>
             </a:r>
@@ -2516,9 +2516,9 @@
                 <a:solidFill>
                   <a:srgbClr val="2E2420"/>
                 </a:solidFill>
-                <a:latin typeface="Tahoma" pitchFamily="34" charset="0"/>
-                <a:ea typeface="Tahoma" pitchFamily="34" charset="-122"/>
-                <a:cs typeface="Tahoma" pitchFamily="34" charset="-120"/>
+                <a:latin typeface="Sarabun" pitchFamily="34" charset="0"/>
+                <a:ea typeface="Sarabun" pitchFamily="34" charset="-122"/>
+                <a:cs typeface="Sarabun" pitchFamily="34" charset="-120"/>
               </a:rPr>
               <a:t>Claude Code สร้างระบบ</a:t>
             </a:r>
@@ -2555,9 +2555,9 @@
                 <a:solidFill>
                   <a:srgbClr val="8A6F57"/>
                 </a:solidFill>
-                <a:latin typeface="Tahoma" pitchFamily="34" charset="0"/>
-                <a:ea typeface="Tahoma" pitchFamily="34" charset="-122"/>
-                <a:cs typeface="Tahoma" pitchFamily="34" charset="-120"/>
+                <a:latin typeface="Sarabun" pitchFamily="34" charset="0"/>
+                <a:ea typeface="Sarabun" pitchFamily="34" charset="-122"/>
+                <a:cs typeface="Sarabun" pitchFamily="34" charset="-120"/>
               </a:rPr>
               <a:t>เรียนผ่านเคสจริง: ร้านกาแฟ ☕</a:t>
             </a:r>
@@ -2666,9 +2666,9 @@
                 <a:solidFill>
                   <a:srgbClr val="AD3A38"/>
                 </a:solidFill>
-                <a:latin typeface="Tahoma" pitchFamily="34" charset="0"/>
-                <a:ea typeface="Tahoma" pitchFamily="34" charset="-122"/>
-                <a:cs typeface="Tahoma" pitchFamily="34" charset="-120"/>
+                <a:latin typeface="Chonburi" pitchFamily="34" charset="0"/>
+                <a:ea typeface="Chonburi" pitchFamily="34" charset="-122"/>
+                <a:cs typeface="Chonburi" pitchFamily="34" charset="-120"/>
               </a:rPr>
               <a:t>เดโม่ 3 องก์</a:t>
             </a:r>
@@ -2771,9 +2771,9 @@
                 <a:solidFill>
                   <a:srgbClr val="2E2420"/>
                 </a:solidFill>
-                <a:latin typeface="Tahoma" pitchFamily="34" charset="0"/>
-                <a:ea typeface="Tahoma" pitchFamily="34" charset="-122"/>
-                <a:cs typeface="Tahoma" pitchFamily="34" charset="-120"/>
+                <a:latin typeface="Sarabun" pitchFamily="34" charset="0"/>
+                <a:ea typeface="Sarabun" pitchFamily="34" charset="-122"/>
+                <a:cs typeface="Sarabun" pitchFamily="34" charset="-120"/>
               </a:rPr>
               <a:t>1. ให้ Claude สำรวจโฟลเดอร์</a:t>
             </a:r>
@@ -2810,9 +2810,9 @@
                 <a:solidFill>
                   <a:srgbClr val="AD3A38"/>
                 </a:solidFill>
-                <a:latin typeface="Tahoma" pitchFamily="34" charset="0"/>
-                <a:ea typeface="Tahoma" pitchFamily="34" charset="-122"/>
-                <a:cs typeface="Tahoma" pitchFamily="34" charset="-120"/>
+                <a:latin typeface="Sarabun" pitchFamily="34" charset="0"/>
+                <a:ea typeface="Sarabun" pitchFamily="34" charset="-122"/>
+                <a:cs typeface="Sarabun" pitchFamily="34" charset="-120"/>
               </a:rPr>
               <a:t>“อ่านไฟล์ทั้งหมด แล้วเล่าว่าร้านนี้ทำธุรกิจอะไร”</a:t>
             </a:r>
@@ -2849,9 +2849,9 @@
                 <a:solidFill>
                   <a:srgbClr val="8A6F57"/>
                 </a:solidFill>
-                <a:latin typeface="Tahoma" pitchFamily="34" charset="0"/>
-                <a:ea typeface="Tahoma" pitchFamily="34" charset="-122"/>
-                <a:cs typeface="Tahoma" pitchFamily="34" charset="-120"/>
+                <a:latin typeface="Sarabun" pitchFamily="34" charset="0"/>
+                <a:ea typeface="Sarabun" pitchFamily="34" charset="-122"/>
+                <a:cs typeface="Sarabun" pitchFamily="34" charset="-120"/>
               </a:rPr>
               <a:t>มันเปิดอ่านเองทุกไฟล์ โดยเราไม่ต้องเปิดสักไฟล์</a:t>
             </a:r>
@@ -2954,9 +2954,9 @@
                 <a:solidFill>
                   <a:srgbClr val="2E2420"/>
                 </a:solidFill>
-                <a:latin typeface="Tahoma" pitchFamily="34" charset="0"/>
-                <a:ea typeface="Tahoma" pitchFamily="34" charset="-122"/>
-                <a:cs typeface="Tahoma" pitchFamily="34" charset="-120"/>
+                <a:latin typeface="Sarabun" pitchFamily="34" charset="0"/>
+                <a:ea typeface="Sarabun" pitchFamily="34" charset="-122"/>
+                <a:cs typeface="Sarabun" pitchFamily="34" charset="-120"/>
               </a:rPr>
               <a:t>2. สรุปอีเมล + ทำตารางนัด</a:t>
             </a:r>
@@ -2993,9 +2993,9 @@
                 <a:solidFill>
                   <a:srgbClr val="AD3A38"/>
                 </a:solidFill>
-                <a:latin typeface="Tahoma" pitchFamily="34" charset="0"/>
-                <a:ea typeface="Tahoma" pitchFamily="34" charset="-122"/>
-                <a:cs typeface="Tahoma" pitchFamily="34" charset="-120"/>
+                <a:latin typeface="Sarabun" pitchFamily="34" charset="0"/>
+                <a:ea typeface="Sarabun" pitchFamily="34" charset="-122"/>
+                <a:cs typeface="Sarabun" pitchFamily="34" charset="-120"/>
               </a:rPr>
               <a:t>“สรุปอีเมล 4 ฉบับ เรียงตามความด่วน แล้วดึงเดดไลน์ทำ schedule.md”</a:t>
             </a:r>
@@ -3032,9 +3032,9 @@
                 <a:solidFill>
                   <a:srgbClr val="8A6F57"/>
                 </a:solidFill>
-                <a:latin typeface="Tahoma" pitchFamily="34" charset="0"/>
-                <a:ea typeface="Tahoma" pitchFamily="34" charset="-122"/>
-                <a:cs typeface="Tahoma" pitchFamily="34" charset="-120"/>
+                <a:latin typeface="Sarabun" pitchFamily="34" charset="0"/>
+                <a:ea typeface="Sarabun" pitchFamily="34" charset="-122"/>
+                <a:cs typeface="Sarabun" pitchFamily="34" charset="-120"/>
               </a:rPr>
               <a:t>มีเดดไลน์ชนกันซ่อนอยู่ — ดูซิว่ามันจับได้ไหม</a:t>
             </a:r>
@@ -3137,9 +3137,9 @@
                 <a:solidFill>
                   <a:srgbClr val="2E2420"/>
                 </a:solidFill>
-                <a:latin typeface="Tahoma" pitchFamily="34" charset="0"/>
-                <a:ea typeface="Tahoma" pitchFamily="34" charset="-122"/>
-                <a:cs typeface="Tahoma" pitchFamily="34" charset="-120"/>
+                <a:latin typeface="Sarabun" pitchFamily="34" charset="0"/>
+                <a:ea typeface="Sarabun" pitchFamily="34" charset="-122"/>
+                <a:cs typeface="Sarabun" pitchFamily="34" charset="-120"/>
               </a:rPr>
               <a:t>3. วิเคราะห์ยอดขาย + สร้างรายงาน</a:t>
             </a:r>
@@ -3176,9 +3176,9 @@
                 <a:solidFill>
                   <a:srgbClr val="AD3A38"/>
                 </a:solidFill>
-                <a:latin typeface="Tahoma" pitchFamily="34" charset="0"/>
-                <a:ea typeface="Tahoma" pitchFamily="34" charset="-122"/>
-                <a:cs typeface="Tahoma" pitchFamily="34" charset="-120"/>
+                <a:latin typeface="Sarabun" pitchFamily="34" charset="0"/>
+                <a:ea typeface="Sarabun" pitchFamily="34" charset="-122"/>
+                <a:cs typeface="Sarabun" pitchFamily="34" charset="-120"/>
               </a:rPr>
               <a:t>“เมนูไหนขายดี? เมนูไหนกำไรดี? ช่องทางไหนโต? สรุปเป็น report.md”</a:t>
             </a:r>
@@ -3215,9 +3215,9 @@
                 <a:solidFill>
                   <a:srgbClr val="8A6F57"/>
                 </a:solidFill>
-                <a:latin typeface="Tahoma" pitchFamily="34" charset="0"/>
-                <a:ea typeface="Tahoma" pitchFamily="34" charset="-122"/>
-                <a:cs typeface="Tahoma" pitchFamily="34" charset="-120"/>
+                <a:latin typeface="Sarabun" pitchFamily="34" charset="0"/>
+                <a:ea typeface="Sarabun" pitchFamily="34" charset="-122"/>
+                <a:cs typeface="Sarabun" pitchFamily="34" charset="-120"/>
               </a:rPr>
               <a:t>เฉลย: ขายดีสุด ≠ กำไรดีสุด</a:t>
             </a:r>
@@ -3326,9 +3326,9 @@
                 <a:solidFill>
                   <a:srgbClr val="AD3A38"/>
                 </a:solidFill>
-                <a:latin typeface="Tahoma" pitchFamily="34" charset="0"/>
-                <a:ea typeface="Tahoma" pitchFamily="34" charset="-122"/>
-                <a:cs typeface="Tahoma" pitchFamily="34" charset="-120"/>
+                <a:latin typeface="Chonburi" pitchFamily="34" charset="0"/>
+                <a:ea typeface="Chonburi" pitchFamily="34" charset="-122"/>
+                <a:cs typeface="Chonburi" pitchFamily="34" charset="-120"/>
               </a:rPr>
               <a:t>ถึงตาคุณ — เวิร์กช็อป 45 นาที</a:t>
             </a:r>
@@ -3385,9 +3385,9 @@
                 <a:solidFill>
                   <a:srgbClr val="FFFFFF"/>
                 </a:solidFill>
-                <a:latin typeface="Tahoma" pitchFamily="34" charset="0"/>
-                <a:ea typeface="Tahoma" pitchFamily="34" charset="-122"/>
-                <a:cs typeface="Tahoma" pitchFamily="34" charset="-120"/>
+                <a:latin typeface="Sarabun" pitchFamily="34" charset="0"/>
+                <a:ea typeface="Sarabun" pitchFamily="34" charset="-122"/>
+                <a:cs typeface="Sarabun" pitchFamily="34" charset="-120"/>
               </a:rPr>
               <a:t>1</a:t>
             </a:r>
@@ -3424,9 +3424,9 @@
                 <a:solidFill>
                   <a:srgbClr val="2E2420"/>
                 </a:solidFill>
-                <a:latin typeface="Tahoma" pitchFamily="34" charset="0"/>
-                <a:ea typeface="Tahoma" pitchFamily="34" charset="-122"/>
-                <a:cs typeface="Tahoma" pitchFamily="34" charset="-120"/>
+                <a:latin typeface="Sarabun" pitchFamily="34" charset="0"/>
+                <a:ea typeface="Sarabun" pitchFamily="34" charset="-122"/>
+                <a:cs typeface="Sarabun" pitchFamily="34" charset="-120"/>
               </a:rPr>
               <a:t>สร้างโฟลเดอร์ my-workshop บน Desktop แล้วลากไฟล์งานของคุณใส่</a:t>
             </a:r>
@@ -3483,9 +3483,9 @@
                 <a:solidFill>
                   <a:srgbClr val="FFFFFF"/>
                 </a:solidFill>
-                <a:latin typeface="Tahoma" pitchFamily="34" charset="0"/>
-                <a:ea typeface="Tahoma" pitchFamily="34" charset="-122"/>
-                <a:cs typeface="Tahoma" pitchFamily="34" charset="-120"/>
+                <a:latin typeface="Sarabun" pitchFamily="34" charset="0"/>
+                <a:ea typeface="Sarabun" pitchFamily="34" charset="-122"/>
+                <a:cs typeface="Sarabun" pitchFamily="34" charset="-120"/>
               </a:rPr>
               <a:t>2</a:t>
             </a:r>
@@ -3522,9 +3522,9 @@
                 <a:solidFill>
                   <a:srgbClr val="2E2420"/>
                 </a:solidFill>
-                <a:latin typeface="Tahoma" pitchFamily="34" charset="0"/>
-                <a:ea typeface="Tahoma" pitchFamily="34" charset="-122"/>
-                <a:cs typeface="Tahoma" pitchFamily="34" charset="-120"/>
+                <a:latin typeface="Sarabun" pitchFamily="34" charset="0"/>
+                <a:ea typeface="Sarabun" pitchFamily="34" charset="-122"/>
+                <a:cs typeface="Sarabun" pitchFamily="34" charset="-120"/>
               </a:rPr>
               <a:t>เปิด Cowork ชี้ไปที่โฟลเดอร์นั้น</a:t>
             </a:r>
@@ -3581,9 +3581,9 @@
                 <a:solidFill>
                   <a:srgbClr val="FFFFFF"/>
                 </a:solidFill>
-                <a:latin typeface="Tahoma" pitchFamily="34" charset="0"/>
-                <a:ea typeface="Tahoma" pitchFamily="34" charset="-122"/>
-                <a:cs typeface="Tahoma" pitchFamily="34" charset="-120"/>
+                <a:latin typeface="Sarabun" pitchFamily="34" charset="0"/>
+                <a:ea typeface="Sarabun" pitchFamily="34" charset="-122"/>
+                <a:cs typeface="Sarabun" pitchFamily="34" charset="-120"/>
               </a:rPr>
               <a:t>3</a:t>
             </a:r>
@@ -3620,9 +3620,9 @@
                 <a:solidFill>
                   <a:srgbClr val="2E2420"/>
                 </a:solidFill>
-                <a:latin typeface="Tahoma" pitchFamily="34" charset="0"/>
-                <a:ea typeface="Tahoma" pitchFamily="34" charset="-122"/>
-                <a:cs typeface="Tahoma" pitchFamily="34" charset="-120"/>
+                <a:latin typeface="Sarabun" pitchFamily="34" charset="0"/>
+                <a:ea typeface="Sarabun" pitchFamily="34" charset="-122"/>
+                <a:cs typeface="Sarabun" pitchFamily="34" charset="-120"/>
               </a:rPr>
               <a:t>prompt แรก: “อ่านไฟล์ในโฟลเดอร์นี้ แล้วบอกว่าช่วยอะไรฉันได้บ้าง”</a:t>
             </a:r>
@@ -3679,9 +3679,9 @@
                 <a:solidFill>
                   <a:srgbClr val="FFFFFF"/>
                 </a:solidFill>
-                <a:latin typeface="Tahoma" pitchFamily="34" charset="0"/>
-                <a:ea typeface="Tahoma" pitchFamily="34" charset="-122"/>
-                <a:cs typeface="Tahoma" pitchFamily="34" charset="-120"/>
+                <a:latin typeface="Sarabun" pitchFamily="34" charset="0"/>
+                <a:ea typeface="Sarabun" pitchFamily="34" charset="-122"/>
+                <a:cs typeface="Sarabun" pitchFamily="34" charset="-120"/>
               </a:rPr>
               <a:t>4</a:t>
             </a:r>
@@ -3718,9 +3718,9 @@
                 <a:solidFill>
                   <a:srgbClr val="2E2420"/>
                 </a:solidFill>
-                <a:latin typeface="Tahoma" pitchFamily="34" charset="0"/>
-                <a:ea typeface="Tahoma" pitchFamily="34" charset="-122"/>
-                <a:cs typeface="Tahoma" pitchFamily="34" charset="-120"/>
+                <a:latin typeface="Sarabun" pitchFamily="34" charset="0"/>
+                <a:ea typeface="Sarabun" pitchFamily="34" charset="-122"/>
+                <a:cs typeface="Sarabun" pitchFamily="34" charset="-120"/>
               </a:rPr>
               <a:t>เลือกไอเดียที่มันเสนอ 1 อย่าง แล้วสั่งด้วยสูตร 4 ส่วน</a:t>
             </a:r>
@@ -3777,9 +3777,9 @@
                 <a:solidFill>
                   <a:srgbClr val="FFFFFF"/>
                 </a:solidFill>
-                <a:latin typeface="Tahoma" pitchFamily="34" charset="0"/>
-                <a:ea typeface="Tahoma" pitchFamily="34" charset="-122"/>
-                <a:cs typeface="Tahoma" pitchFamily="34" charset="-120"/>
+                <a:latin typeface="Sarabun" pitchFamily="34" charset="0"/>
+                <a:ea typeface="Sarabun" pitchFamily="34" charset="-122"/>
+                <a:cs typeface="Sarabun" pitchFamily="34" charset="-120"/>
               </a:rPr>
               <a:t>5</a:t>
             </a:r>
@@ -3816,9 +3816,9 @@
                 <a:solidFill>
                   <a:srgbClr val="2E2420"/>
                 </a:solidFill>
-                <a:latin typeface="Tahoma" pitchFamily="34" charset="0"/>
-                <a:ea typeface="Tahoma" pitchFamily="34" charset="-122"/>
-                <a:cs typeface="Tahoma" pitchFamily="34" charset="-120"/>
+                <a:latin typeface="Sarabun" pitchFamily="34" charset="0"/>
+                <a:ea typeface="Sarabun" pitchFamily="34" charset="-122"/>
+                <a:cs typeface="Sarabun" pitchFamily="34" charset="-120"/>
               </a:rPr>
               <a:t>ไม่ถูกใจ → สั่งแก้อย่างน้อย 2 รอบ</a:t>
             </a:r>
@@ -3875,9 +3875,9 @@
                 <a:solidFill>
                   <a:srgbClr val="FFFFFF"/>
                 </a:solidFill>
-                <a:latin typeface="Tahoma" pitchFamily="34" charset="0"/>
-                <a:ea typeface="Tahoma" pitchFamily="34" charset="-122"/>
-                <a:cs typeface="Tahoma" pitchFamily="34" charset="-120"/>
+                <a:latin typeface="Sarabun" pitchFamily="34" charset="0"/>
+                <a:ea typeface="Sarabun" pitchFamily="34" charset="-122"/>
+                <a:cs typeface="Sarabun" pitchFamily="34" charset="-120"/>
               </a:rPr>
               <a:t>6</a:t>
             </a:r>
@@ -3914,9 +3914,9 @@
                 <a:solidFill>
                   <a:srgbClr val="2E2420"/>
                 </a:solidFill>
-                <a:latin typeface="Tahoma" pitchFamily="34" charset="0"/>
-                <a:ea typeface="Tahoma" pitchFamily="34" charset="-122"/>
-                <a:cs typeface="Tahoma" pitchFamily="34" charset="-120"/>
+                <a:latin typeface="Sarabun" pitchFamily="34" charset="0"/>
+                <a:ea typeface="Sarabun" pitchFamily="34" charset="-122"/>
+                <a:cs typeface="Sarabun" pitchFamily="34" charset="-120"/>
               </a:rPr>
               <a:t>ปิดท้าย: ให้มันสร้างไฟล์ผลลัพธ์เก็บไว้ (รายงาน / Excel)</a:t>
             </a:r>
@@ -3975,9 +3975,9 @@
                 <a:solidFill>
                   <a:srgbClr val="FFCB64"/>
                 </a:solidFill>
-                <a:latin typeface="Tahoma" pitchFamily="34" charset="0"/>
-                <a:ea typeface="Tahoma" pitchFamily="34" charset="-122"/>
-                <a:cs typeface="Tahoma" pitchFamily="34" charset="-120"/>
+                <a:latin typeface="Sarabun" pitchFamily="34" charset="0"/>
+                <a:ea typeface="Sarabun" pitchFamily="34" charset="-122"/>
+                <a:cs typeface="Sarabun" pitchFamily="34" charset="-120"/>
               </a:rPr>
               <a:t>ไม่ได้เอาไฟล์มา?</a:t>
             </a:r>
@@ -4014,9 +4014,9 @@
                 <a:solidFill>
                   <a:srgbClr val="FBEBD0"/>
                 </a:solidFill>
-                <a:latin typeface="Tahoma" pitchFamily="34" charset="0"/>
-                <a:ea typeface="Tahoma" pitchFamily="34" charset="-122"/>
-                <a:cs typeface="Tahoma" pitchFamily="34" charset="-120"/>
+                <a:latin typeface="Sarabun" pitchFamily="34" charset="0"/>
+                <a:ea typeface="Sarabun" pitchFamily="34" charset="-122"/>
+                <a:cs typeface="Sarabun" pitchFamily="34" charset="-120"/>
               </a:rPr>
               <a:t>ใช้โฟลเดอร์ร้านกาแฟได้เลย มีโจทย์ให้ 3 ระดับ:</a:t>
             </a:r>
@@ -4056,9 +4056,9 @@
                 <a:solidFill>
                   <a:srgbClr val="CFE3B8"/>
                 </a:solidFill>
-                <a:latin typeface="Tahoma" pitchFamily="34" charset="0"/>
-                <a:ea typeface="Tahoma" pitchFamily="34" charset="-122"/>
-                <a:cs typeface="Tahoma" pitchFamily="34" charset="-120"/>
+                <a:latin typeface="Sarabun" pitchFamily="34" charset="0"/>
+                <a:ea typeface="Sarabun" pitchFamily="34" charset="-122"/>
+                <a:cs typeface="Sarabun" pitchFamily="34" charset="-120"/>
               </a:rPr>
               <a:t>ง่าย: </a:t>
             </a:r>
@@ -4073,9 +4073,9 @@
                 <a:solidFill>
                   <a:srgbClr val="FBEBD0"/>
                 </a:solidFill>
-                <a:latin typeface="Tahoma" pitchFamily="34" charset="0"/>
-                <a:ea typeface="Tahoma" pitchFamily="34" charset="-122"/>
-                <a:cs typeface="Tahoma" pitchFamily="34" charset="-120"/>
+                <a:latin typeface="Sarabun" pitchFamily="34" charset="0"/>
+                <a:ea typeface="Sarabun" pitchFamily="34" charset="-122"/>
+                <a:cs typeface="Sarabun" pitchFamily="34" charset="-120"/>
               </a:rPr>
               <a:t>ข้อความขอบคุณลูกค้าแต้มสูงสุด 5 คน
 </a:t>
@@ -4091,9 +4091,9 @@
                 <a:solidFill>
                   <a:srgbClr val="FFCB64"/>
                 </a:solidFill>
-                <a:latin typeface="Tahoma" pitchFamily="34" charset="0"/>
-                <a:ea typeface="Tahoma" pitchFamily="34" charset="-122"/>
-                <a:cs typeface="Tahoma" pitchFamily="34" charset="-120"/>
+                <a:latin typeface="Sarabun" pitchFamily="34" charset="0"/>
+                <a:ea typeface="Sarabun" pitchFamily="34" charset="-122"/>
+                <a:cs typeface="Sarabun" pitchFamily="34" charset="-120"/>
               </a:rPr>
               <a:t>กลาง: </a:t>
             </a:r>
@@ -4108,9 +4108,9 @@
                 <a:solidFill>
                   <a:srgbClr val="FBEBD0"/>
                 </a:solidFill>
-                <a:latin typeface="Tahoma" pitchFamily="34" charset="0"/>
-                <a:ea typeface="Tahoma" pitchFamily="34" charset="-122"/>
-                <a:cs typeface="Tahoma" pitchFamily="34" charset="-120"/>
+                <a:latin typeface="Sarabun" pitchFamily="34" charset="0"/>
+                <a:ea typeface="Sarabun" pitchFamily="34" charset="-122"/>
+                <a:cs typeface="Sarabun" pitchFamily="34" charset="-120"/>
               </a:rPr>
               <a:t>ร่างใบเสนอราคาบูธ 18,000 บาท
 </a:t>
@@ -4126,9 +4126,9 @@
                 <a:solidFill>
                   <a:srgbClr val="F3C8B8"/>
                 </a:solidFill>
-                <a:latin typeface="Tahoma" pitchFamily="34" charset="0"/>
-                <a:ea typeface="Tahoma" pitchFamily="34" charset="-122"/>
-                <a:cs typeface="Tahoma" pitchFamily="34" charset="-120"/>
+                <a:latin typeface="Sarabun" pitchFamily="34" charset="0"/>
+                <a:ea typeface="Sarabun" pitchFamily="34" charset="-122"/>
+                <a:cs typeface="Sarabun" pitchFamily="34" charset="-120"/>
               </a:rPr>
               <a:t>ยาก: </a:t>
             </a:r>
@@ -4143,9 +4143,9 @@
                 <a:solidFill>
                   <a:srgbClr val="FBEBD0"/>
                 </a:solidFill>
-                <a:latin typeface="Tahoma" pitchFamily="34" charset="0"/>
-                <a:ea typeface="Tahoma" pitchFamily="34" charset="-122"/>
-                <a:cs typeface="Tahoma" pitchFamily="34" charset="-120"/>
+                <a:latin typeface="Sarabun" pitchFamily="34" charset="0"/>
+                <a:ea typeface="Sarabun" pitchFamily="34" charset="-122"/>
+                <a:cs typeface="Sarabun" pitchFamily="34" charset="-120"/>
               </a:rPr>
               <a:t>ออกแบบโปรฯ ช่วงบ่ายจากข้อมูลจริง</a:t>
             </a:r>
@@ -4182,9 +4182,9 @@
                 <a:solidFill>
                   <a:srgbClr val="C65E52"/>
                 </a:solidFill>
-                <a:latin typeface="Tahoma" pitchFamily="34" charset="0"/>
-                <a:ea typeface="Tahoma" pitchFamily="34" charset="-122"/>
-                <a:cs typeface="Tahoma" pitchFamily="34" charset="-120"/>
+                <a:latin typeface="Sarabun" pitchFamily="34" charset="0"/>
+                <a:ea typeface="Sarabun" pitchFamily="34" charset="-122"/>
+                <a:cs typeface="Sarabun" pitchFamily="34" charset="-120"/>
               </a:rPr>
               <a:t>10 นาทีสุดท้าย: อาสาสมัคร 2–3 คน โชว์ผลงานหน้าห้อง</a:t>
             </a:r>
@@ -4313,9 +4313,9 @@
                 <a:solidFill>
                   <a:srgbClr val="C65E52"/>
                 </a:solidFill>
-                <a:latin typeface="Tahoma" pitchFamily="34" charset="0"/>
-                <a:ea typeface="Tahoma" pitchFamily="34" charset="-122"/>
-                <a:cs typeface="Tahoma" pitchFamily="34" charset="-120"/>
+                <a:latin typeface="Chonburi" pitchFamily="34" charset="0"/>
+                <a:ea typeface="Chonburi" pitchFamily="34" charset="-122"/>
+                <a:cs typeface="Chonburi" pitchFamily="34" charset="-120"/>
               </a:rPr>
               <a:t>ช่วงที่ 3</a:t>
             </a:r>
@@ -4352,9 +4352,9 @@
                 <a:solidFill>
                   <a:srgbClr val="AD3A38"/>
                 </a:solidFill>
-                <a:latin typeface="Tahoma" pitchFamily="34" charset="0"/>
-                <a:ea typeface="Tahoma" pitchFamily="34" charset="-122"/>
-                <a:cs typeface="Tahoma" pitchFamily="34" charset="-120"/>
+                <a:latin typeface="Chonburi" pitchFamily="34" charset="0"/>
+                <a:ea typeface="Chonburi" pitchFamily="34" charset="-122"/>
+                <a:cs typeface="Chonburi" pitchFamily="34" charset="-120"/>
               </a:rPr>
               <a:t>Claude Code: สั่งสร้างระบบเองได้</a:t>
             </a:r>
@@ -4391,9 +4391,9 @@
                 <a:solidFill>
                   <a:srgbClr val="2E2420"/>
                 </a:solidFill>
-                <a:latin typeface="Tahoma" pitchFamily="34" charset="0"/>
-                <a:ea typeface="Tahoma" pitchFamily="34" charset="-122"/>
-                <a:cs typeface="Tahoma" pitchFamily="34" charset="-120"/>
+                <a:latin typeface="Sarabun" pitchFamily="34" charset="0"/>
+                <a:ea typeface="Sarabun" pitchFamily="34" charset="-122"/>
+                <a:cs typeface="Sarabun" pitchFamily="34" charset="-120"/>
               </a:rPr>
               <a:t>เพื่อนเจ้าของร้านกาแฟบ่นว่า “อยากมี Dashboard สวยๆ แบบร้านใหญ่ แต่จ้างคนทำโปรแกรมก็แพง” — งั้นสร้างกันตรงนี้เลย</a:t>
             </a:r>
@@ -4502,9 +4502,9 @@
                 <a:solidFill>
                   <a:srgbClr val="AD3A38"/>
                 </a:solidFill>
-                <a:latin typeface="Tahoma" pitchFamily="34" charset="0"/>
-                <a:ea typeface="Tahoma" pitchFamily="34" charset="-122"/>
-                <a:cs typeface="Tahoma" pitchFamily="34" charset="-120"/>
+                <a:latin typeface="Chonburi" pitchFamily="34" charset="0"/>
+                <a:ea typeface="Chonburi" pitchFamily="34" charset="-122"/>
+                <a:cs typeface="Chonburi" pitchFamily="34" charset="-120"/>
               </a:rPr>
               <a:t>จากไฟล์ Excel ธรรมดา → ระบบใช้งานจริง</a:t>
             </a:r>
@@ -4572,9 +4572,9 @@
                 <a:solidFill>
                   <a:srgbClr val="8A6F57"/>
                 </a:solidFill>
-                <a:latin typeface="Tahoma" pitchFamily="34" charset="0"/>
-                <a:ea typeface="Tahoma" pitchFamily="34" charset="-122"/>
-                <a:cs typeface="Tahoma" pitchFamily="34" charset="-120"/>
+                <a:latin typeface="Sarabun" pitchFamily="34" charset="0"/>
+                <a:ea typeface="Sarabun" pitchFamily="34" charset="-122"/>
+                <a:cs typeface="Sarabun" pitchFamily="34" charset="-120"/>
               </a:rPr>
               <a:t>Dashboard ที่สร้างจากข้อมูลร้านในเดโม่เมื่อกี้ — ของจริง ไม่ใช่ภาพตัวอย่าง</a:t>
             </a:r>
@@ -4655,9 +4655,9 @@
                 <a:solidFill>
                   <a:srgbClr val="2E2420"/>
                 </a:solidFill>
-                <a:latin typeface="Tahoma" pitchFamily="34" charset="0"/>
-                <a:ea typeface="Tahoma" pitchFamily="34" charset="-122"/>
-                <a:cs typeface="Tahoma" pitchFamily="34" charset="-120"/>
+                <a:latin typeface="Sarabun" pitchFamily="34" charset="0"/>
+                <a:ea typeface="Sarabun" pitchFamily="34" charset="-122"/>
+                <a:cs typeface="Sarabun" pitchFamily="34" charset="-120"/>
               </a:rPr>
               <a:t>ใช้เวลา ~15 นาที ไม่เขียนโค้ดเองสักบรรทัด</a:t>
             </a:r>
@@ -4738,9 +4738,9 @@
                 <a:solidFill>
                   <a:srgbClr val="2E2420"/>
                 </a:solidFill>
-                <a:latin typeface="Tahoma" pitchFamily="34" charset="0"/>
-                <a:ea typeface="Tahoma" pitchFamily="34" charset="-122"/>
-                <a:cs typeface="Tahoma" pitchFamily="34" charset="-120"/>
+                <a:latin typeface="Sarabun" pitchFamily="34" charset="0"/>
+                <a:ea typeface="Sarabun" pitchFamily="34" charset="-122"/>
+                <a:cs typeface="Sarabun" pitchFamily="34" charset="-120"/>
               </a:rPr>
               <a:t>สั่งแก้ต่อได้ด้วยภาษาคน: “เพิ่มช่องค้นหาสมาชิก” “เปลี่ยนเป็นโหมดมืด”</a:t>
             </a:r>
@@ -4821,9 +4821,9 @@
                 <a:solidFill>
                   <a:srgbClr val="2E2420"/>
                 </a:solidFill>
-                <a:latin typeface="Tahoma" pitchFamily="34" charset="0"/>
-                <a:ea typeface="Tahoma" pitchFamily="34" charset="-122"/>
-                <a:cs typeface="Tahoma" pitchFamily="34" charset="-120"/>
+                <a:latin typeface="Sarabun" pitchFamily="34" charset="0"/>
+                <a:ea typeface="Sarabun" pitchFamily="34" charset="-122"/>
+                <a:cs typeface="Sarabun" pitchFamily="34" charset="-120"/>
               </a:rPr>
               <a:t>ระบบจริงจังกว่านี้ (เชื่อม POS, หลายสาขา) ก็เริ่มจากการคุยแบบเดียวกัน</a:t>
             </a:r>
@@ -4882,9 +4882,9 @@
                 <a:solidFill>
                   <a:srgbClr val="AD3A38"/>
                 </a:solidFill>
-                <a:latin typeface="Tahoma" pitchFamily="34" charset="0"/>
-                <a:ea typeface="Tahoma" pitchFamily="34" charset="-122"/>
-                <a:cs typeface="Tahoma" pitchFamily="34" charset="-120"/>
+                <a:latin typeface="Sarabun" pitchFamily="34" charset="0"/>
+                <a:ea typeface="Sarabun" pitchFamily="34" charset="-122"/>
+                <a:cs typeface="Sarabun" pitchFamily="34" charset="-120"/>
               </a:rPr>
               <a:t>คำถามกลับบ้าน:
 </a:t>
@@ -4897,9 +4897,9 @@
                 <a:solidFill>
                   <a:srgbClr val="2E2420"/>
                 </a:solidFill>
-                <a:latin typeface="Tahoma" pitchFamily="34" charset="0"/>
-                <a:ea typeface="Tahoma" pitchFamily="34" charset="-122"/>
-                <a:cs typeface="Tahoma" pitchFamily="34" charset="-120"/>
+                <a:latin typeface="Sarabun" pitchFamily="34" charset="0"/>
+                <a:ea typeface="Sarabun" pitchFamily="34" charset="-122"/>
+                <a:cs typeface="Sarabun" pitchFamily="34" charset="-120"/>
               </a:rPr>
               <a:t>“ระบบอะไรในงานของคุณ ที่อยากได้มานาน แต่คิดว่าต้องจ้างคนทำ?”</a:t>
             </a:r>
@@ -5008,9 +5008,9 @@
                 <a:solidFill>
                   <a:srgbClr val="AD3A38"/>
                 </a:solidFill>
-                <a:latin typeface="Tahoma" pitchFamily="34" charset="0"/>
-                <a:ea typeface="Tahoma" pitchFamily="34" charset="-122"/>
-                <a:cs typeface="Tahoma" pitchFamily="34" charset="-120"/>
+                <a:latin typeface="Chonburi" pitchFamily="34" charset="0"/>
+                <a:ea typeface="Chonburi" pitchFamily="34" charset="-122"/>
+                <a:cs typeface="Chonburi" pitchFamily="34" charset="-120"/>
               </a:rPr>
               <a:t>3 อย่างที่ขอให้จำออกไปจากห้องนี้</a:t>
             </a:r>
@@ -5120,9 +5120,9 @@
                 <a:solidFill>
                   <a:srgbClr val="2E2420"/>
                 </a:solidFill>
-                <a:latin typeface="Tahoma" pitchFamily="34" charset="0"/>
-                <a:ea typeface="Tahoma" pitchFamily="34" charset="-122"/>
-                <a:cs typeface="Tahoma" pitchFamily="34" charset="-120"/>
+                <a:latin typeface="Sarabun" pitchFamily="34" charset="0"/>
+                <a:ea typeface="Sarabun" pitchFamily="34" charset="-122"/>
+                <a:cs typeface="Sarabun" pitchFamily="34" charset="-120"/>
               </a:rPr>
               <a:t>สูตร 4 ส่วน</a:t>
             </a:r>
@@ -5159,9 +5159,9 @@
                 <a:solidFill>
                   <a:srgbClr val="8A6F57"/>
                 </a:solidFill>
-                <a:latin typeface="Tahoma" pitchFamily="34" charset="0"/>
-                <a:ea typeface="Tahoma" pitchFamily="34" charset="-122"/>
-                <a:cs typeface="Tahoma" pitchFamily="34" charset="-120"/>
+                <a:latin typeface="Sarabun" pitchFamily="34" charset="0"/>
+                <a:ea typeface="Sarabun" pitchFamily="34" charset="-122"/>
+                <a:cs typeface="Sarabun" pitchFamily="34" charset="-120"/>
               </a:rPr>
               <a:t>บทบาท + งาน + บริบท + รูปแบบผลลัพธ์</a:t>
             </a:r>
@@ -5271,9 +5271,9 @@
                 <a:solidFill>
                   <a:srgbClr val="2E2420"/>
                 </a:solidFill>
-                <a:latin typeface="Tahoma" pitchFamily="34" charset="0"/>
-                <a:ea typeface="Tahoma" pitchFamily="34" charset="-122"/>
-                <a:cs typeface="Tahoma" pitchFamily="34" charset="-120"/>
+                <a:latin typeface="Sarabun" pitchFamily="34" charset="0"/>
+                <a:ea typeface="Sarabun" pitchFamily="34" charset="-122"/>
+                <a:cs typeface="Sarabun" pitchFamily="34" charset="-120"/>
               </a:rPr>
               <a:t>กฎทอง</a:t>
             </a:r>
@@ -5310,9 +5310,9 @@
                 <a:solidFill>
                   <a:srgbClr val="8A6F57"/>
                 </a:solidFill>
-                <a:latin typeface="Tahoma" pitchFamily="34" charset="0"/>
-                <a:ea typeface="Tahoma" pitchFamily="34" charset="-122"/>
-                <a:cs typeface="Tahoma" pitchFamily="34" charset="-120"/>
+                <a:latin typeface="Sarabun" pitchFamily="34" charset="0"/>
+                <a:ea typeface="Sarabun" pitchFamily="34" charset="-122"/>
+                <a:cs typeface="Sarabun" pitchFamily="34" charset="-120"/>
               </a:rPr>
               <a:t>ไม่ถูกใจ → สั่งแก้ต่อ</a:t>
             </a:r>
@@ -5327,9 +5327,9 @@
                 <a:solidFill>
                   <a:srgbClr val="8A6F57"/>
                 </a:solidFill>
-                <a:latin typeface="Tahoma" pitchFamily="34" charset="0"/>
-                <a:ea typeface="Tahoma" pitchFamily="34" charset="-122"/>
-                <a:cs typeface="Tahoma" pitchFamily="34" charset="-120"/>
+                <a:latin typeface="Sarabun" pitchFamily="34" charset="0"/>
+                <a:ea typeface="Sarabun" pitchFamily="34" charset="-122"/>
+                <a:cs typeface="Sarabun" pitchFamily="34" charset="-120"/>
               </a:rPr>
               <a:t>คิดไม่ออก → ถามมันว่าช่วยอะไรได้บ้าง</a:t>
             </a:r>
@@ -5439,9 +5439,9 @@
                 <a:solidFill>
                   <a:srgbClr val="2E2420"/>
                 </a:solidFill>
-                <a:latin typeface="Tahoma" pitchFamily="34" charset="0"/>
-                <a:ea typeface="Tahoma" pitchFamily="34" charset="-122"/>
-                <a:cs typeface="Tahoma" pitchFamily="34" charset="-120"/>
+                <a:latin typeface="Sarabun" pitchFamily="34" charset="0"/>
+                <a:ea typeface="Sarabun" pitchFamily="34" charset="-122"/>
+                <a:cs typeface="Sarabun" pitchFamily="34" charset="-120"/>
               </a:rPr>
               <a:t>ระวัง 3 ข้อ</a:t>
             </a:r>
@@ -5478,9 +5478,9 @@
                 <a:solidFill>
                   <a:srgbClr val="8A6F57"/>
                 </a:solidFill>
-                <a:latin typeface="Tahoma" pitchFamily="34" charset="0"/>
-                <a:ea typeface="Tahoma" pitchFamily="34" charset="-122"/>
-                <a:cs typeface="Tahoma" pitchFamily="34" charset="-120"/>
+                <a:latin typeface="Sarabun" pitchFamily="34" charset="0"/>
+                <a:ea typeface="Sarabun" pitchFamily="34" charset="-122"/>
+                <a:cs typeface="Sarabun" pitchFamily="34" charset="-120"/>
               </a:rPr>
               <a:t>ตรวจก่อนใช้ • คิดก่อนอัปโหลด</a:t>
             </a:r>
@@ -5495,9 +5495,9 @@
                 <a:solidFill>
                   <a:srgbClr val="8A6F57"/>
                 </a:solidFill>
-                <a:latin typeface="Tahoma" pitchFamily="34" charset="0"/>
-                <a:ea typeface="Tahoma" pitchFamily="34" charset="-122"/>
-                <a:cs typeface="Tahoma" pitchFamily="34" charset="-120"/>
+                <a:latin typeface="Sarabun" pitchFamily="34" charset="0"/>
+                <a:ea typeface="Sarabun" pitchFamily="34" charset="-122"/>
+                <a:cs typeface="Sarabun" pitchFamily="34" charset="-120"/>
               </a:rPr>
               <a:t>คนตัดสินใจ ไม่ใช่ AI</a:t>
             </a:r>
@@ -5534,9 +5534,9 @@
                 <a:solidFill>
                   <a:srgbClr val="C65E52"/>
                 </a:solidFill>
-                <a:latin typeface="Tahoma" pitchFamily="34" charset="0"/>
-                <a:ea typeface="Tahoma" pitchFamily="34" charset="-122"/>
-                <a:cs typeface="Tahoma" pitchFamily="34" charset="-120"/>
+                <a:latin typeface="Sarabun" pitchFamily="34" charset="0"/>
+                <a:ea typeface="Sarabun" pitchFamily="34" charset="-122"/>
+                <a:cs typeface="Sarabun" pitchFamily="34" charset="-120"/>
               </a:rPr>
               <a:t>ทั้งหมดนี้อยู่ใน Cheat Sheet ที่แจก — แปะไว้ข้างจอได้เลย</a:t>
             </a:r>
@@ -5705,9 +5705,9 @@
                 <a:solidFill>
                   <a:srgbClr val="AD3A38"/>
                 </a:solidFill>
-                <a:latin typeface="Tahoma" pitchFamily="34" charset="0"/>
-                <a:ea typeface="Tahoma" pitchFamily="34" charset="-122"/>
-                <a:cs typeface="Tahoma" pitchFamily="34" charset="-120"/>
+                <a:latin typeface="Chonburi" pitchFamily="34" charset="0"/>
+                <a:ea typeface="Chonburi" pitchFamily="34" charset="-122"/>
+                <a:cs typeface="Chonburi" pitchFamily="34" charset="-120"/>
               </a:rPr>
               <a:t>การบ้าน</a:t>
             </a:r>
@@ -5744,9 +5744,9 @@
                 <a:solidFill>
                   <a:srgbClr val="2E2420"/>
                 </a:solidFill>
-                <a:latin typeface="Tahoma" pitchFamily="34" charset="0"/>
-                <a:ea typeface="Tahoma" pitchFamily="34" charset="-122"/>
-                <a:cs typeface="Tahoma" pitchFamily="34" charset="-120"/>
+                <a:latin typeface="Sarabun" pitchFamily="34" charset="0"/>
+                <a:ea typeface="Sarabun" pitchFamily="34" charset="-122"/>
+                <a:cs typeface="Sarabun" pitchFamily="34" charset="-120"/>
               </a:rPr>
               <a:t>ใช้ AI กับงานจริงของคุณ 3 ครั้ง ภายในสัปดาห์นี้</a:t>
             </a:r>
@@ -5783,9 +5783,9 @@
                 <a:solidFill>
                   <a:srgbClr val="8A6F57"/>
                 </a:solidFill>
-                <a:latin typeface="Tahoma" pitchFamily="34" charset="0"/>
-                <a:ea typeface="Tahoma" pitchFamily="34" charset="-122"/>
-                <a:cs typeface="Tahoma" pitchFamily="34" charset="-120"/>
+                <a:latin typeface="Sarabun" pitchFamily="34" charset="0"/>
+                <a:ea typeface="Sarabun" pitchFamily="34" charset="-122"/>
+                <a:cs typeface="Sarabun" pitchFamily="34" charset="-120"/>
               </a:rPr>
               <a:t>แล้วมาเล่าในกลุ่มไลน์ว่า อันไหนเวิร์ก อันไหนไม่เวิร์ก — ตัวอย่างจากเพื่อนคือครูที่ดีที่สุด</a:t>
             </a:r>
@@ -5895,9 +5895,9 @@
                 <a:solidFill>
                   <a:srgbClr val="2E2420"/>
                 </a:solidFill>
-                <a:latin typeface="Tahoma" pitchFamily="34" charset="0"/>
-                <a:ea typeface="Tahoma" pitchFamily="34" charset="-122"/>
-                <a:cs typeface="Tahoma" pitchFamily="34" charset="-120"/>
+                <a:latin typeface="Sarabun" pitchFamily="34" charset="0"/>
+                <a:ea typeface="Sarabun" pitchFamily="34" charset="-122"/>
+                <a:cs typeface="Sarabun" pitchFamily="34" charset="-120"/>
               </a:rPr>
               <a:t>เข้ากลุ่มไลน์คลาส</a:t>
             </a:r>
@@ -6007,9 +6007,9 @@
                 <a:solidFill>
                   <a:srgbClr val="2E2420"/>
                 </a:solidFill>
-                <a:latin typeface="Tahoma" pitchFamily="34" charset="0"/>
-                <a:ea typeface="Tahoma" pitchFamily="34" charset="-122"/>
-                <a:cs typeface="Tahoma" pitchFamily="34" charset="-120"/>
+                <a:latin typeface="Sarabun" pitchFamily="34" charset="0"/>
+                <a:ea typeface="Sarabun" pitchFamily="34" charset="-122"/>
+                <a:cs typeface="Sarabun" pitchFamily="34" charset="-120"/>
               </a:rPr>
               <a:t>โหลดโฟลเดอร์เดโม่ไปลองต่อ</a:t>
             </a:r>
@@ -6119,9 +6119,9 @@
                 <a:solidFill>
                   <a:srgbClr val="2E2420"/>
                 </a:solidFill>
-                <a:latin typeface="Tahoma" pitchFamily="34" charset="0"/>
-                <a:ea typeface="Tahoma" pitchFamily="34" charset="-122"/>
-                <a:cs typeface="Tahoma" pitchFamily="34" charset="-120"/>
+                <a:latin typeface="Sarabun" pitchFamily="34" charset="0"/>
+                <a:ea typeface="Sarabun" pitchFamily="34" charset="-122"/>
+                <a:cs typeface="Sarabun" pitchFamily="34" charset="-120"/>
               </a:rPr>
               <a:t>Cheat Sheet อยู่ในมือแล้ว</a:t>
             </a:r>
@@ -6158,9 +6158,9 @@
                 <a:solidFill>
                   <a:srgbClr val="C65E52"/>
                 </a:solidFill>
-                <a:latin typeface="Tahoma" pitchFamily="34" charset="0"/>
-                <a:ea typeface="Tahoma" pitchFamily="34" charset="-122"/>
-                <a:cs typeface="Tahoma" pitchFamily="34" charset="-120"/>
+                <a:latin typeface="Sarabun" pitchFamily="34" charset="0"/>
+                <a:ea typeface="Sarabun" pitchFamily="34" charset="-122"/>
+                <a:cs typeface="Sarabun" pitchFamily="34" charset="-120"/>
               </a:rPr>
               <a:t>ขอบคุณครับ ☕ มีคำถามถามได้เลย</a:t>
             </a:r>
@@ -6269,9 +6269,9 @@
                 <a:solidFill>
                   <a:srgbClr val="AD3A38"/>
                 </a:solidFill>
-                <a:latin typeface="Tahoma" pitchFamily="34" charset="0"/>
-                <a:ea typeface="Tahoma" pitchFamily="34" charset="-122"/>
-                <a:cs typeface="Tahoma" pitchFamily="34" charset="-120"/>
+                <a:latin typeface="Chonburi" pitchFamily="34" charset="0"/>
+                <a:ea typeface="Chonburi" pitchFamily="34" charset="-122"/>
+                <a:cs typeface="Chonburi" pitchFamily="34" charset="-120"/>
               </a:rPr>
               <a:t>วันนี้เราจะทำอะไรกันบ้าง</a:t>
             </a:r>
@@ -6330,9 +6330,9 @@
                 <a:solidFill>
                   <a:srgbClr val="AD3A38"/>
                 </a:solidFill>
-                <a:latin typeface="Tahoma" pitchFamily="34" charset="0"/>
-                <a:ea typeface="Tahoma" pitchFamily="34" charset="-122"/>
-                <a:cs typeface="Tahoma" pitchFamily="34" charset="-120"/>
+                <a:latin typeface="Sarabun" pitchFamily="34" charset="0"/>
+                <a:ea typeface="Sarabun" pitchFamily="34" charset="-122"/>
+                <a:cs typeface="Sarabun" pitchFamily="34" charset="-120"/>
               </a:rPr>
               <a:t>0:00</a:t>
             </a:r>
@@ -6369,9 +6369,9 @@
                 <a:solidFill>
                   <a:srgbClr val="2E2420"/>
                 </a:solidFill>
-                <a:latin typeface="Tahoma" pitchFamily="34" charset="0"/>
-                <a:ea typeface="Tahoma" pitchFamily="34" charset="-122"/>
-                <a:cs typeface="Tahoma" pitchFamily="34" charset="-120"/>
+                <a:latin typeface="Sarabun" pitchFamily="34" charset="0"/>
+                <a:ea typeface="Sarabun" pitchFamily="34" charset="-122"/>
+                <a:cs typeface="Sarabun" pitchFamily="34" charset="-120"/>
               </a:rPr>
               <a:t>ปูพื้นฐาน — โลก AI ตอนนี้เป็นยังไง</a:t>
             </a:r>
@@ -6408,9 +6408,9 @@
                 <a:solidFill>
                   <a:srgbClr val="8A6F57"/>
                 </a:solidFill>
-                <a:latin typeface="Tahoma" pitchFamily="34" charset="0"/>
-                <a:ea typeface="Tahoma" pitchFamily="34" charset="-122"/>
-                <a:cs typeface="Tahoma" pitchFamily="34" charset="-120"/>
+                <a:latin typeface="Sarabun" pitchFamily="34" charset="0"/>
+                <a:ea typeface="Sarabun" pitchFamily="34" charset="-122"/>
+                <a:cs typeface="Sarabun" pitchFamily="34" charset="-120"/>
               </a:rPr>
               <a:t>15 นาที</a:t>
             </a:r>
@@ -6469,9 +6469,9 @@
                 <a:solidFill>
                   <a:srgbClr val="AD3A38"/>
                 </a:solidFill>
-                <a:latin typeface="Tahoma" pitchFamily="34" charset="0"/>
-                <a:ea typeface="Tahoma" pitchFamily="34" charset="-122"/>
-                <a:cs typeface="Tahoma" pitchFamily="34" charset="-120"/>
+                <a:latin typeface="Sarabun" pitchFamily="34" charset="0"/>
+                <a:ea typeface="Sarabun" pitchFamily="34" charset="-122"/>
+                <a:cs typeface="Sarabun" pitchFamily="34" charset="-120"/>
               </a:rPr>
               <a:t>0:15</a:t>
             </a:r>
@@ -6508,9 +6508,9 @@
                 <a:solidFill>
                   <a:srgbClr val="2E2420"/>
                 </a:solidFill>
-                <a:latin typeface="Tahoma" pitchFamily="34" charset="0"/>
-                <a:ea typeface="Tahoma" pitchFamily="34" charset="-122"/>
-                <a:cs typeface="Tahoma" pitchFamily="34" charset="-120"/>
+                <a:latin typeface="Sarabun" pitchFamily="34" charset="0"/>
+                <a:ea typeface="Sarabun" pitchFamily="34" charset="-122"/>
+                <a:cs typeface="Sarabun" pitchFamily="34" charset="-120"/>
               </a:rPr>
               <a:t>รู้จัก Cowork + สูตรสั่งงาน 4 ส่วน</a:t>
             </a:r>
@@ -6547,9 +6547,9 @@
                 <a:solidFill>
                   <a:srgbClr val="8A6F57"/>
                 </a:solidFill>
-                <a:latin typeface="Tahoma" pitchFamily="34" charset="0"/>
-                <a:ea typeface="Tahoma" pitchFamily="34" charset="-122"/>
-                <a:cs typeface="Tahoma" pitchFamily="34" charset="-120"/>
+                <a:latin typeface="Sarabun" pitchFamily="34" charset="0"/>
+                <a:ea typeface="Sarabun" pitchFamily="34" charset="-122"/>
+                <a:cs typeface="Sarabun" pitchFamily="34" charset="-120"/>
               </a:rPr>
               <a:t>15 นาที</a:t>
             </a:r>
@@ -6608,9 +6608,9 @@
                 <a:solidFill>
                   <a:srgbClr val="FFFFFF"/>
                 </a:solidFill>
-                <a:latin typeface="Tahoma" pitchFamily="34" charset="0"/>
-                <a:ea typeface="Tahoma" pitchFamily="34" charset="-122"/>
-                <a:cs typeface="Tahoma" pitchFamily="34" charset="-120"/>
+                <a:latin typeface="Sarabun" pitchFamily="34" charset="0"/>
+                <a:ea typeface="Sarabun" pitchFamily="34" charset="-122"/>
+                <a:cs typeface="Sarabun" pitchFamily="34" charset="-120"/>
               </a:rPr>
               <a:t>0:30</a:t>
             </a:r>
@@ -6647,9 +6647,9 @@
                 <a:solidFill>
                   <a:srgbClr val="2E2420"/>
                 </a:solidFill>
-                <a:latin typeface="Tahoma" pitchFamily="34" charset="0"/>
-                <a:ea typeface="Tahoma" pitchFamily="34" charset="-122"/>
-                <a:cs typeface="Tahoma" pitchFamily="34" charset="-120"/>
+                <a:latin typeface="Sarabun" pitchFamily="34" charset="0"/>
+                <a:ea typeface="Sarabun" pitchFamily="34" charset="-122"/>
+                <a:cs typeface="Sarabun" pitchFamily="34" charset="-120"/>
               </a:rPr>
               <a:t>เดโม่สด: เคสร้านกาแฟ (อีเมล • ตารางนัด • ยอดขาย)</a:t>
             </a:r>
@@ -6686,9 +6686,9 @@
                 <a:solidFill>
                   <a:srgbClr val="8A6F57"/>
                 </a:solidFill>
-                <a:latin typeface="Tahoma" pitchFamily="34" charset="0"/>
-                <a:ea typeface="Tahoma" pitchFamily="34" charset="-122"/>
-                <a:cs typeface="Tahoma" pitchFamily="34" charset="-120"/>
+                <a:latin typeface="Sarabun" pitchFamily="34" charset="0"/>
+                <a:ea typeface="Sarabun" pitchFamily="34" charset="-122"/>
+                <a:cs typeface="Sarabun" pitchFamily="34" charset="-120"/>
               </a:rPr>
               <a:t>45 นาที</a:t>
             </a:r>
@@ -6747,9 +6747,9 @@
                 <a:solidFill>
                   <a:srgbClr val="FFFFFF"/>
                 </a:solidFill>
-                <a:latin typeface="Tahoma" pitchFamily="34" charset="0"/>
-                <a:ea typeface="Tahoma" pitchFamily="34" charset="-122"/>
-                <a:cs typeface="Tahoma" pitchFamily="34" charset="-120"/>
+                <a:latin typeface="Sarabun" pitchFamily="34" charset="0"/>
+                <a:ea typeface="Sarabun" pitchFamily="34" charset="-122"/>
+                <a:cs typeface="Sarabun" pitchFamily="34" charset="-120"/>
               </a:rPr>
               <a:t>1:25</a:t>
             </a:r>
@@ -6786,9 +6786,9 @@
                 <a:solidFill>
                   <a:srgbClr val="2E2420"/>
                 </a:solidFill>
-                <a:latin typeface="Tahoma" pitchFamily="34" charset="0"/>
-                <a:ea typeface="Tahoma" pitchFamily="34" charset="-122"/>
-                <a:cs typeface="Tahoma" pitchFamily="34" charset="-120"/>
+                <a:latin typeface="Sarabun" pitchFamily="34" charset="0"/>
+                <a:ea typeface="Sarabun" pitchFamily="34" charset="-122"/>
+                <a:cs typeface="Sarabun" pitchFamily="34" charset="-120"/>
               </a:rPr>
               <a:t>เวิร์กช็อป: ลองกับไฟล์งานของคุณเอง</a:t>
             </a:r>
@@ -6825,9 +6825,9 @@
                 <a:solidFill>
                   <a:srgbClr val="8A6F57"/>
                 </a:solidFill>
-                <a:latin typeface="Tahoma" pitchFamily="34" charset="0"/>
-                <a:ea typeface="Tahoma" pitchFamily="34" charset="-122"/>
-                <a:cs typeface="Tahoma" pitchFamily="34" charset="-120"/>
+                <a:latin typeface="Sarabun" pitchFamily="34" charset="0"/>
+                <a:ea typeface="Sarabun" pitchFamily="34" charset="-122"/>
+                <a:cs typeface="Sarabun" pitchFamily="34" charset="-120"/>
               </a:rPr>
               <a:t>45 นาที</a:t>
             </a:r>
@@ -6886,9 +6886,9 @@
                 <a:solidFill>
                   <a:srgbClr val="FFFFFF"/>
                 </a:solidFill>
-                <a:latin typeface="Tahoma" pitchFamily="34" charset="0"/>
-                <a:ea typeface="Tahoma" pitchFamily="34" charset="-122"/>
-                <a:cs typeface="Tahoma" pitchFamily="34" charset="-120"/>
+                <a:latin typeface="Sarabun" pitchFamily="34" charset="0"/>
+                <a:ea typeface="Sarabun" pitchFamily="34" charset="-122"/>
+                <a:cs typeface="Sarabun" pitchFamily="34" charset="-120"/>
               </a:rPr>
               <a:t>2:10</a:t>
             </a:r>
@@ -6925,9 +6925,9 @@
                 <a:solidFill>
                   <a:srgbClr val="2E2420"/>
                 </a:solidFill>
-                <a:latin typeface="Tahoma" pitchFamily="34" charset="0"/>
-                <a:ea typeface="Tahoma" pitchFamily="34" charset="-122"/>
-                <a:cs typeface="Tahoma" pitchFamily="34" charset="-120"/>
+                <a:latin typeface="Sarabun" pitchFamily="34" charset="0"/>
+                <a:ea typeface="Sarabun" pitchFamily="34" charset="-122"/>
+                <a:cs typeface="Sarabun" pitchFamily="34" charset="-120"/>
               </a:rPr>
               <a:t>Claude Code: สั่งสร้างระบบ Dashboard</a:t>
             </a:r>
@@ -6964,9 +6964,9 @@
                 <a:solidFill>
                   <a:srgbClr val="8A6F57"/>
                 </a:solidFill>
-                <a:latin typeface="Tahoma" pitchFamily="34" charset="0"/>
-                <a:ea typeface="Tahoma" pitchFamily="34" charset="-122"/>
-                <a:cs typeface="Tahoma" pitchFamily="34" charset="-120"/>
+                <a:latin typeface="Sarabun" pitchFamily="34" charset="0"/>
+                <a:ea typeface="Sarabun" pitchFamily="34" charset="-122"/>
+                <a:cs typeface="Sarabun" pitchFamily="34" charset="-120"/>
               </a:rPr>
               <a:t>40 นาที</a:t>
             </a:r>
@@ -7025,9 +7025,9 @@
                 <a:solidFill>
                   <a:srgbClr val="AD3A38"/>
                 </a:solidFill>
-                <a:latin typeface="Tahoma" pitchFamily="34" charset="0"/>
-                <a:ea typeface="Tahoma" pitchFamily="34" charset="-122"/>
-                <a:cs typeface="Tahoma" pitchFamily="34" charset="-120"/>
+                <a:latin typeface="Sarabun" pitchFamily="34" charset="0"/>
+                <a:ea typeface="Sarabun" pitchFamily="34" charset="-122"/>
+                <a:cs typeface="Sarabun" pitchFamily="34" charset="-120"/>
               </a:rPr>
               <a:t>2:50</a:t>
             </a:r>
@@ -7064,9 +7064,9 @@
                 <a:solidFill>
                   <a:srgbClr val="2E2420"/>
                 </a:solidFill>
-                <a:latin typeface="Tahoma" pitchFamily="34" charset="0"/>
-                <a:ea typeface="Tahoma" pitchFamily="34" charset="-122"/>
-                <a:cs typeface="Tahoma" pitchFamily="34" charset="-120"/>
+                <a:latin typeface="Sarabun" pitchFamily="34" charset="0"/>
+                <a:ea typeface="Sarabun" pitchFamily="34" charset="-122"/>
+                <a:cs typeface="Sarabun" pitchFamily="34" charset="-120"/>
               </a:rPr>
               <a:t>สรุป + แจก Cheat Sheet + Q&amp;A</a:t>
             </a:r>
@@ -7103,9 +7103,9 @@
                 <a:solidFill>
                   <a:srgbClr val="8A6F57"/>
                 </a:solidFill>
-                <a:latin typeface="Tahoma" pitchFamily="34" charset="0"/>
-                <a:ea typeface="Tahoma" pitchFamily="34" charset="-122"/>
-                <a:cs typeface="Tahoma" pitchFamily="34" charset="-120"/>
+                <a:latin typeface="Sarabun" pitchFamily="34" charset="0"/>
+                <a:ea typeface="Sarabun" pitchFamily="34" charset="-122"/>
+                <a:cs typeface="Sarabun" pitchFamily="34" charset="-120"/>
               </a:rPr>
               <a:t>10 นาที</a:t>
             </a:r>
@@ -7164,9 +7164,9 @@
                 <a:solidFill>
                   <a:srgbClr val="FFCB64"/>
                 </a:solidFill>
-                <a:latin typeface="Tahoma" pitchFamily="34" charset="0"/>
-                <a:ea typeface="Tahoma" pitchFamily="34" charset="-122"/>
-                <a:cs typeface="Tahoma" pitchFamily="34" charset="-120"/>
+                <a:latin typeface="Chonburi" pitchFamily="34" charset="0"/>
+                <a:ea typeface="Chonburi" pitchFamily="34" charset="-122"/>
+                <a:cs typeface="Chonburi" pitchFamily="34" charset="-120"/>
               </a:rPr>
               <a:t>3</a:t>
             </a:r>
@@ -7203,9 +7203,9 @@
                 <a:solidFill>
                   <a:srgbClr val="FBEBD0"/>
                 </a:solidFill>
-                <a:latin typeface="Tahoma" pitchFamily="34" charset="0"/>
-                <a:ea typeface="Tahoma" pitchFamily="34" charset="-122"/>
-                <a:cs typeface="Tahoma" pitchFamily="34" charset="-120"/>
+                <a:latin typeface="Sarabun" pitchFamily="34" charset="0"/>
+                <a:ea typeface="Sarabun" pitchFamily="34" charset="-122"/>
+                <a:cs typeface="Sarabun" pitchFamily="34" charset="-120"/>
               </a:rPr>
               <a:t>ชั่วโมง</a:t>
             </a:r>
@@ -7220,9 +7220,9 @@
                 <a:solidFill>
                   <a:srgbClr val="FBEBD0"/>
                 </a:solidFill>
-                <a:latin typeface="Tahoma" pitchFamily="34" charset="0"/>
-                <a:ea typeface="Tahoma" pitchFamily="34" charset="-122"/>
-                <a:cs typeface="Tahoma" pitchFamily="34" charset="-120"/>
+                <a:latin typeface="Sarabun" pitchFamily="34" charset="0"/>
+                <a:ea typeface="Sarabun" pitchFamily="34" charset="-122"/>
+                <a:cs typeface="Sarabun" pitchFamily="34" charset="-120"/>
               </a:rPr>
               <a:t>จบในครั้งเดียว</a:t>
             </a:r>
@@ -7351,9 +7351,9 @@
                 <a:solidFill>
                   <a:srgbClr val="C65E52"/>
                 </a:solidFill>
-                <a:latin typeface="Tahoma" pitchFamily="34" charset="0"/>
-                <a:ea typeface="Tahoma" pitchFamily="34" charset="-122"/>
-                <a:cs typeface="Tahoma" pitchFamily="34" charset="-120"/>
+                <a:latin typeface="Chonburi" pitchFamily="34" charset="0"/>
+                <a:ea typeface="Chonburi" pitchFamily="34" charset="-122"/>
+                <a:cs typeface="Chonburi" pitchFamily="34" charset="-120"/>
               </a:rPr>
               <a:t>ช่วงที่ 1</a:t>
             </a:r>
@@ -7390,9 +7390,9 @@
                 <a:solidFill>
                   <a:srgbClr val="AD3A38"/>
                 </a:solidFill>
-                <a:latin typeface="Tahoma" pitchFamily="34" charset="0"/>
-                <a:ea typeface="Tahoma" pitchFamily="34" charset="-122"/>
-                <a:cs typeface="Tahoma" pitchFamily="34" charset="-120"/>
+                <a:latin typeface="Chonburi" pitchFamily="34" charset="0"/>
+                <a:ea typeface="Chonburi" pitchFamily="34" charset="-122"/>
+                <a:cs typeface="Chonburi" pitchFamily="34" charset="-120"/>
               </a:rPr>
               <a:t>โลก AI ตอนนี้เป็นยังไง</a:t>
             </a:r>
@@ -7429,9 +7429,9 @@
                 <a:solidFill>
                   <a:srgbClr val="2E2420"/>
                 </a:solidFill>
-                <a:latin typeface="Tahoma" pitchFamily="34" charset="0"/>
-                <a:ea typeface="Tahoma" pitchFamily="34" charset="-122"/>
-                <a:cs typeface="Tahoma" pitchFamily="34" charset="-120"/>
+                <a:latin typeface="Sarabun" pitchFamily="34" charset="0"/>
+                <a:ea typeface="Sarabun" pitchFamily="34" charset="-122"/>
+                <a:cs typeface="Sarabun" pitchFamily="34" charset="-120"/>
               </a:rPr>
               <a:t>15 นาที — ไม่มีศัพท์เทคนิค สัญญา</a:t>
             </a:r>
@@ -7540,9 +7540,9 @@
                 <a:solidFill>
                   <a:srgbClr val="AD3A38"/>
                 </a:solidFill>
-                <a:latin typeface="Tahoma" pitchFamily="34" charset="0"/>
-                <a:ea typeface="Tahoma" pitchFamily="34" charset="-122"/>
-                <a:cs typeface="Tahoma" pitchFamily="34" charset="-120"/>
+                <a:latin typeface="Chonburi" pitchFamily="34" charset="0"/>
+                <a:ea typeface="Chonburi" pitchFamily="34" charset="-122"/>
+                <a:cs typeface="Chonburi" pitchFamily="34" charset="-120"/>
               </a:rPr>
               <a:t>AI ยุคนี้ = ผู้ช่วยที่คุยด้วยภาษาคนได้</a:t>
             </a:r>
@@ -7579,9 +7579,9 @@
                 <a:solidFill>
                   <a:srgbClr val="8A6F57"/>
                 </a:solidFill>
-                <a:latin typeface="Tahoma" pitchFamily="34" charset="0"/>
-                <a:ea typeface="Tahoma" pitchFamily="34" charset="-122"/>
-                <a:cs typeface="Tahoma" pitchFamily="34" charset="-120"/>
+                <a:latin typeface="Sarabun" pitchFamily="34" charset="0"/>
+                <a:ea typeface="Sarabun" pitchFamily="34" charset="-122"/>
+                <a:cs typeface="Sarabun" pitchFamily="34" charset="-120"/>
               </a:rPr>
               <a:t>ไม่ใช่หุ่นยนต์ ไม่ใช่ Google — พิมพ์คุยเหมือนคุยกับเพื่อนร่วมงานคนหนึ่ง</a:t>
             </a:r>
@@ -7684,9 +7684,9 @@
                 <a:solidFill>
                   <a:srgbClr val="2E2420"/>
                 </a:solidFill>
-                <a:latin typeface="Tahoma" pitchFamily="34" charset="0"/>
-                <a:ea typeface="Tahoma" pitchFamily="34" charset="-122"/>
-                <a:cs typeface="Tahoma" pitchFamily="34" charset="-120"/>
+                <a:latin typeface="Sarabun" pitchFamily="34" charset="0"/>
+                <a:ea typeface="Sarabun" pitchFamily="34" charset="-122"/>
+                <a:cs typeface="Sarabun" pitchFamily="34" charset="-120"/>
               </a:rPr>
               <a:t>อ่าน</a:t>
             </a:r>
@@ -7723,9 +7723,9 @@
                 <a:solidFill>
                   <a:srgbClr val="8A6F57"/>
                 </a:solidFill>
-                <a:latin typeface="Tahoma" pitchFamily="34" charset="0"/>
-                <a:ea typeface="Tahoma" pitchFamily="34" charset="-122"/>
-                <a:cs typeface="Tahoma" pitchFamily="34" charset="-120"/>
+                <a:latin typeface="Sarabun" pitchFamily="34" charset="0"/>
+                <a:ea typeface="Sarabun" pitchFamily="34" charset="-122"/>
+                <a:cs typeface="Sarabun" pitchFamily="34" charset="-120"/>
               </a:rPr>
               <a:t>เอกสาร สัญญา อีเมล</a:t>
             </a:r>
@@ -7740,9 +7740,9 @@
                 <a:solidFill>
                   <a:srgbClr val="8A6F57"/>
                 </a:solidFill>
-                <a:latin typeface="Tahoma" pitchFamily="34" charset="0"/>
-                <a:ea typeface="Tahoma" pitchFamily="34" charset="-122"/>
-                <a:cs typeface="Tahoma" pitchFamily="34" charset="-120"/>
+                <a:latin typeface="Sarabun" pitchFamily="34" charset="0"/>
+                <a:ea typeface="Sarabun" pitchFamily="34" charset="-122"/>
+                <a:cs typeface="Sarabun" pitchFamily="34" charset="-120"/>
               </a:rPr>
               <a:t>ยาวแค่ไหนก็ไหว</a:t>
             </a:r>
@@ -7845,9 +7845,9 @@
                 <a:solidFill>
                   <a:srgbClr val="2E2420"/>
                 </a:solidFill>
-                <a:latin typeface="Tahoma" pitchFamily="34" charset="0"/>
-                <a:ea typeface="Tahoma" pitchFamily="34" charset="-122"/>
-                <a:cs typeface="Tahoma" pitchFamily="34" charset="-120"/>
+                <a:latin typeface="Sarabun" pitchFamily="34" charset="0"/>
+                <a:ea typeface="Sarabun" pitchFamily="34" charset="-122"/>
+                <a:cs typeface="Sarabun" pitchFamily="34" charset="-120"/>
               </a:rPr>
               <a:t>เขียน</a:t>
             </a:r>
@@ -7884,9 +7884,9 @@
                 <a:solidFill>
                   <a:srgbClr val="8A6F57"/>
                 </a:solidFill>
-                <a:latin typeface="Tahoma" pitchFamily="34" charset="0"/>
-                <a:ea typeface="Tahoma" pitchFamily="34" charset="-122"/>
-                <a:cs typeface="Tahoma" pitchFamily="34" charset="-120"/>
+                <a:latin typeface="Sarabun" pitchFamily="34" charset="0"/>
+                <a:ea typeface="Sarabun" pitchFamily="34" charset="-122"/>
+                <a:cs typeface="Sarabun" pitchFamily="34" charset="-120"/>
               </a:rPr>
               <a:t>สรุป ร่างอีเมล แปลภาษา</a:t>
             </a:r>
@@ -7901,9 +7901,9 @@
                 <a:solidFill>
                   <a:srgbClr val="8A6F57"/>
                 </a:solidFill>
-                <a:latin typeface="Tahoma" pitchFamily="34" charset="0"/>
-                <a:ea typeface="Tahoma" pitchFamily="34" charset="-122"/>
-                <a:cs typeface="Tahoma" pitchFamily="34" charset="-120"/>
+                <a:latin typeface="Sarabun" pitchFamily="34" charset="0"/>
+                <a:ea typeface="Sarabun" pitchFamily="34" charset="-122"/>
+                <a:cs typeface="Sarabun" pitchFamily="34" charset="-120"/>
               </a:rPr>
               <a:t>ปรับโทนได้ตามสั่ง</a:t>
             </a:r>
@@ -8006,9 +8006,9 @@
                 <a:solidFill>
                   <a:srgbClr val="2E2420"/>
                 </a:solidFill>
-                <a:latin typeface="Tahoma" pitchFamily="34" charset="0"/>
-                <a:ea typeface="Tahoma" pitchFamily="34" charset="-122"/>
-                <a:cs typeface="Tahoma" pitchFamily="34" charset="-120"/>
+                <a:latin typeface="Sarabun" pitchFamily="34" charset="0"/>
+                <a:ea typeface="Sarabun" pitchFamily="34" charset="-122"/>
+                <a:cs typeface="Sarabun" pitchFamily="34" charset="-120"/>
               </a:rPr>
               <a:t>คิด</a:t>
             </a:r>
@@ -8045,9 +8045,9 @@
                 <a:solidFill>
                   <a:srgbClr val="8A6F57"/>
                 </a:solidFill>
-                <a:latin typeface="Tahoma" pitchFamily="34" charset="0"/>
-                <a:ea typeface="Tahoma" pitchFamily="34" charset="-122"/>
-                <a:cs typeface="Tahoma" pitchFamily="34" charset="-120"/>
+                <a:latin typeface="Sarabun" pitchFamily="34" charset="0"/>
+                <a:ea typeface="Sarabun" pitchFamily="34" charset="-122"/>
+                <a:cs typeface="Sarabun" pitchFamily="34" charset="-120"/>
               </a:rPr>
               <a:t>วิเคราะห์ข้อมูล เสนอไอเดีย</a:t>
             </a:r>
@@ -8062,9 +8062,9 @@
                 <a:solidFill>
                   <a:srgbClr val="8A6F57"/>
                 </a:solidFill>
-                <a:latin typeface="Tahoma" pitchFamily="34" charset="0"/>
-                <a:ea typeface="Tahoma" pitchFamily="34" charset="-122"/>
-                <a:cs typeface="Tahoma" pitchFamily="34" charset="-120"/>
+                <a:latin typeface="Sarabun" pitchFamily="34" charset="0"/>
+                <a:ea typeface="Sarabun" pitchFamily="34" charset="-122"/>
+                <a:cs typeface="Sarabun" pitchFamily="34" charset="-120"/>
               </a:rPr>
               <a:t>ช่วยตัดสินใจ</a:t>
             </a:r>
@@ -8167,9 +8167,9 @@
                 <a:solidFill>
                   <a:srgbClr val="2E2420"/>
                 </a:solidFill>
-                <a:latin typeface="Tahoma" pitchFamily="34" charset="0"/>
-                <a:ea typeface="Tahoma" pitchFamily="34" charset="-122"/>
-                <a:cs typeface="Tahoma" pitchFamily="34" charset="-120"/>
+                <a:latin typeface="Sarabun" pitchFamily="34" charset="0"/>
+                <a:ea typeface="Sarabun" pitchFamily="34" charset="-122"/>
+                <a:cs typeface="Sarabun" pitchFamily="34" charset="-120"/>
               </a:rPr>
               <a:t>ลงมือทำ</a:t>
             </a:r>
@@ -8206,9 +8206,9 @@
                 <a:solidFill>
                   <a:srgbClr val="8A6F57"/>
                 </a:solidFill>
-                <a:latin typeface="Tahoma" pitchFamily="34" charset="0"/>
-                <a:ea typeface="Tahoma" pitchFamily="34" charset="-122"/>
-                <a:cs typeface="Tahoma" pitchFamily="34" charset="-120"/>
+                <a:latin typeface="Sarabun" pitchFamily="34" charset="0"/>
+                <a:ea typeface="Sarabun" pitchFamily="34" charset="-122"/>
+                <a:cs typeface="Sarabun" pitchFamily="34" charset="-120"/>
               </a:rPr>
               <a:t>จัดไฟล์ สร้างรายงาน</a:t>
             </a:r>
@@ -8223,9 +8223,9 @@
                 <a:solidFill>
                   <a:srgbClr val="8A6F57"/>
                 </a:solidFill>
-                <a:latin typeface="Tahoma" pitchFamily="34" charset="0"/>
-                <a:ea typeface="Tahoma" pitchFamily="34" charset="-122"/>
-                <a:cs typeface="Tahoma" pitchFamily="34" charset="-120"/>
+                <a:latin typeface="Sarabun" pitchFamily="34" charset="0"/>
+                <a:ea typeface="Sarabun" pitchFamily="34" charset="-122"/>
+                <a:cs typeface="Sarabun" pitchFamily="34" charset="-120"/>
               </a:rPr>
               <a:t>เขียนโปรแกรม</a:t>
             </a:r>
@@ -8262,9 +8262,9 @@
                 <a:solidFill>
                   <a:srgbClr val="C65E52"/>
                 </a:solidFill>
-                <a:latin typeface="Tahoma" pitchFamily="34" charset="0"/>
-                <a:ea typeface="Tahoma" pitchFamily="34" charset="-122"/>
-                <a:cs typeface="Tahoma" pitchFamily="34" charset="-120"/>
+                <a:latin typeface="Sarabun" pitchFamily="34" charset="0"/>
+                <a:ea typeface="Sarabun" pitchFamily="34" charset="-122"/>
+                <a:cs typeface="Sarabun" pitchFamily="34" charset="-120"/>
               </a:rPr>
               <a:t>จุดเปลี่ยนสำคัญ: จากที่เราต้องเรียนรู้วิธีใช้โปรแกรม → ตอนนี้โปรแกรมเข้าใจภาษาเรา</a:t>
             </a:r>
@@ -8373,9 +8373,9 @@
                 <a:solidFill>
                   <a:srgbClr val="AD3A38"/>
                 </a:solidFill>
-                <a:latin typeface="Tahoma" pitchFamily="34" charset="0"/>
-                <a:ea typeface="Tahoma" pitchFamily="34" charset="-122"/>
-                <a:cs typeface="Tahoma" pitchFamily="34" charset="-120"/>
+                <a:latin typeface="Chonburi" pitchFamily="34" charset="0"/>
+                <a:ea typeface="Chonburi" pitchFamily="34" charset="-122"/>
+                <a:cs typeface="Chonburi" pitchFamily="34" charset="-120"/>
               </a:rPr>
               <a:t>ค่ายหลักที่ควรรู้จัก</a:t>
             </a:r>
@@ -8441,9 +8441,9 @@
                 <a:solidFill>
                   <a:srgbClr val="FFFFFF"/>
                 </a:solidFill>
-                <a:latin typeface="Tahoma" pitchFamily="34" charset="0"/>
-                <a:ea typeface="Tahoma" pitchFamily="34" charset="-122"/>
-                <a:cs typeface="Tahoma" pitchFamily="34" charset="-120"/>
+                <a:latin typeface="Sarabun" pitchFamily="34" charset="0"/>
+                <a:ea typeface="Sarabun" pitchFamily="34" charset="-122"/>
+                <a:cs typeface="Sarabun" pitchFamily="34" charset="-120"/>
               </a:rPr>
               <a:t>Claude</a:t>
             </a:r>
@@ -8480,9 +8480,9 @@
                 <a:solidFill>
                   <a:srgbClr val="FFCB64"/>
                 </a:solidFill>
-                <a:latin typeface="Tahoma" pitchFamily="34" charset="0"/>
-                <a:ea typeface="Tahoma" pitchFamily="34" charset="-122"/>
-                <a:cs typeface="Tahoma" pitchFamily="34" charset="-120"/>
+                <a:latin typeface="Sarabun" pitchFamily="34" charset="0"/>
+                <a:ea typeface="Sarabun" pitchFamily="34" charset="-122"/>
+                <a:cs typeface="Sarabun" pitchFamily="34" charset="-120"/>
               </a:rPr>
               <a:t>Anthropic</a:t>
             </a:r>
@@ -8519,9 +8519,9 @@
                 <a:solidFill>
                   <a:srgbClr val="FBEBD0"/>
                 </a:solidFill>
-                <a:latin typeface="Tahoma" pitchFamily="34" charset="0"/>
-                <a:ea typeface="Tahoma" pitchFamily="34" charset="-122"/>
-                <a:cs typeface="Tahoma" pitchFamily="34" charset="-120"/>
+                <a:latin typeface="Sarabun" pitchFamily="34" charset="0"/>
+                <a:ea typeface="Sarabun" pitchFamily="34" charset="-122"/>
+                <a:cs typeface="Sarabun" pitchFamily="34" charset="-120"/>
               </a:rPr>
               <a:t>เก่งงานเอกสารและไฟล์</a:t>
             </a:r>
@@ -8536,9 +8536,9 @@
                 <a:solidFill>
                   <a:srgbClr val="FBEBD0"/>
                 </a:solidFill>
-                <a:latin typeface="Tahoma" pitchFamily="34" charset="0"/>
-                <a:ea typeface="Tahoma" pitchFamily="34" charset="-122"/>
-                <a:cs typeface="Tahoma" pitchFamily="34" charset="-120"/>
+                <a:latin typeface="Sarabun" pitchFamily="34" charset="0"/>
+                <a:ea typeface="Sarabun" pitchFamily="34" charset="-122"/>
+                <a:cs typeface="Sarabun" pitchFamily="34" charset="-120"/>
               </a:rPr>
               <a:t>มี Cowork + Claude Code</a:t>
             </a:r>
@@ -8553,9 +8553,9 @@
                 <a:solidFill>
                   <a:srgbClr val="FBEBD0"/>
                 </a:solidFill>
-                <a:latin typeface="Tahoma" pitchFamily="34" charset="0"/>
-                <a:ea typeface="Tahoma" pitchFamily="34" charset="-122"/>
-                <a:cs typeface="Tahoma" pitchFamily="34" charset="-120"/>
+                <a:latin typeface="Sarabun" pitchFamily="34" charset="0"/>
+                <a:ea typeface="Sarabun" pitchFamily="34" charset="-122"/>
+                <a:cs typeface="Sarabun" pitchFamily="34" charset="-120"/>
               </a:rPr>
               <a:t>(ที่เราใช้วันนี้)</a:t>
             </a:r>
@@ -8621,9 +8621,9 @@
                 <a:solidFill>
                   <a:srgbClr val="2E2420"/>
                 </a:solidFill>
-                <a:latin typeface="Tahoma" pitchFamily="34" charset="0"/>
-                <a:ea typeface="Tahoma" pitchFamily="34" charset="-122"/>
-                <a:cs typeface="Tahoma" pitchFamily="34" charset="-120"/>
+                <a:latin typeface="Sarabun" pitchFamily="34" charset="0"/>
+                <a:ea typeface="Sarabun" pitchFamily="34" charset="-122"/>
+                <a:cs typeface="Sarabun" pitchFamily="34" charset="-120"/>
               </a:rPr>
               <a:t>ChatGPT</a:t>
             </a:r>
@@ -8660,9 +8660,9 @@
                 <a:solidFill>
                   <a:srgbClr val="8A6F57"/>
                 </a:solidFill>
-                <a:latin typeface="Tahoma" pitchFamily="34" charset="0"/>
-                <a:ea typeface="Tahoma" pitchFamily="34" charset="-122"/>
-                <a:cs typeface="Tahoma" pitchFamily="34" charset="-120"/>
+                <a:latin typeface="Sarabun" pitchFamily="34" charset="0"/>
+                <a:ea typeface="Sarabun" pitchFamily="34" charset="-122"/>
+                <a:cs typeface="Sarabun" pitchFamily="34" charset="-120"/>
               </a:rPr>
               <a:t>OpenAI</a:t>
             </a:r>
@@ -8699,9 +8699,9 @@
                 <a:solidFill>
                   <a:srgbClr val="2E2420"/>
                 </a:solidFill>
-                <a:latin typeface="Tahoma" pitchFamily="34" charset="0"/>
-                <a:ea typeface="Tahoma" pitchFamily="34" charset="-122"/>
-                <a:cs typeface="Tahoma" pitchFamily="34" charset="-120"/>
+                <a:latin typeface="Sarabun" pitchFamily="34" charset="0"/>
+                <a:ea typeface="Sarabun" pitchFamily="34" charset="-122"/>
+                <a:cs typeface="Sarabun" pitchFamily="34" charset="-120"/>
               </a:rPr>
               <a:t>คนใช้เยอะที่สุด</a:t>
             </a:r>
@@ -8716,9 +8716,9 @@
                 <a:solidFill>
                   <a:srgbClr val="2E2420"/>
                 </a:solidFill>
-                <a:latin typeface="Tahoma" pitchFamily="34" charset="0"/>
-                <a:ea typeface="Tahoma" pitchFamily="34" charset="-122"/>
-                <a:cs typeface="Tahoma" pitchFamily="34" charset="-120"/>
+                <a:latin typeface="Sarabun" pitchFamily="34" charset="0"/>
+                <a:ea typeface="Sarabun" pitchFamily="34" charset="-122"/>
+                <a:cs typeface="Sarabun" pitchFamily="34" charset="-120"/>
               </a:rPr>
               <a:t>รู้จักแพร่หลายที่สุด</a:t>
             </a:r>
@@ -8784,9 +8784,9 @@
                 <a:solidFill>
                   <a:srgbClr val="2E2420"/>
                 </a:solidFill>
-                <a:latin typeface="Tahoma" pitchFamily="34" charset="0"/>
-                <a:ea typeface="Tahoma" pitchFamily="34" charset="-122"/>
-                <a:cs typeface="Tahoma" pitchFamily="34" charset="-120"/>
+                <a:latin typeface="Sarabun" pitchFamily="34" charset="0"/>
+                <a:ea typeface="Sarabun" pitchFamily="34" charset="-122"/>
+                <a:cs typeface="Sarabun" pitchFamily="34" charset="-120"/>
               </a:rPr>
               <a:t>Gemini</a:t>
             </a:r>
@@ -8823,9 +8823,9 @@
                 <a:solidFill>
                   <a:srgbClr val="8A6F57"/>
                 </a:solidFill>
-                <a:latin typeface="Tahoma" pitchFamily="34" charset="0"/>
-                <a:ea typeface="Tahoma" pitchFamily="34" charset="-122"/>
-                <a:cs typeface="Tahoma" pitchFamily="34" charset="-120"/>
+                <a:latin typeface="Sarabun" pitchFamily="34" charset="0"/>
+                <a:ea typeface="Sarabun" pitchFamily="34" charset="-122"/>
+                <a:cs typeface="Sarabun" pitchFamily="34" charset="-120"/>
               </a:rPr>
               <a:t>Google</a:t>
             </a:r>
@@ -8862,9 +8862,9 @@
                 <a:solidFill>
                   <a:srgbClr val="2E2420"/>
                 </a:solidFill>
-                <a:latin typeface="Tahoma" pitchFamily="34" charset="0"/>
-                <a:ea typeface="Tahoma" pitchFamily="34" charset="-122"/>
-                <a:cs typeface="Tahoma" pitchFamily="34" charset="-120"/>
+                <a:latin typeface="Sarabun" pitchFamily="34" charset="0"/>
+                <a:ea typeface="Sarabun" pitchFamily="34" charset="-122"/>
+                <a:cs typeface="Sarabun" pitchFamily="34" charset="-120"/>
               </a:rPr>
               <a:t>ผูกกับ Gmail,</a:t>
             </a:r>
@@ -8879,9 +8879,9 @@
                 <a:solidFill>
                   <a:srgbClr val="2E2420"/>
                 </a:solidFill>
-                <a:latin typeface="Tahoma" pitchFamily="34" charset="0"/>
-                <a:ea typeface="Tahoma" pitchFamily="34" charset="-122"/>
-                <a:cs typeface="Tahoma" pitchFamily="34" charset="-120"/>
+                <a:latin typeface="Sarabun" pitchFamily="34" charset="0"/>
+                <a:ea typeface="Sarabun" pitchFamily="34" charset="-122"/>
+                <a:cs typeface="Sarabun" pitchFamily="34" charset="-120"/>
               </a:rPr>
               <a:t>Google Docs / Sheets</a:t>
             </a:r>
@@ -8947,9 +8947,9 @@
                 <a:solidFill>
                   <a:srgbClr val="2E2420"/>
                 </a:solidFill>
-                <a:latin typeface="Tahoma" pitchFamily="34" charset="0"/>
-                <a:ea typeface="Tahoma" pitchFamily="34" charset="-122"/>
-                <a:cs typeface="Tahoma" pitchFamily="34" charset="-120"/>
+                <a:latin typeface="Sarabun" pitchFamily="34" charset="0"/>
+                <a:ea typeface="Sarabun" pitchFamily="34" charset="-122"/>
+                <a:cs typeface="Sarabun" pitchFamily="34" charset="-120"/>
               </a:rPr>
               <a:t>Copilot</a:t>
             </a:r>
@@ -8986,9 +8986,9 @@
                 <a:solidFill>
                   <a:srgbClr val="8A6F57"/>
                 </a:solidFill>
-                <a:latin typeface="Tahoma" pitchFamily="34" charset="0"/>
-                <a:ea typeface="Tahoma" pitchFamily="34" charset="-122"/>
-                <a:cs typeface="Tahoma" pitchFamily="34" charset="-120"/>
+                <a:latin typeface="Sarabun" pitchFamily="34" charset="0"/>
+                <a:ea typeface="Sarabun" pitchFamily="34" charset="-122"/>
+                <a:cs typeface="Sarabun" pitchFamily="34" charset="-120"/>
               </a:rPr>
               <a:t>Microsoft</a:t>
             </a:r>
@@ -9025,9 +9025,9 @@
                 <a:solidFill>
                   <a:srgbClr val="2E2420"/>
                 </a:solidFill>
-                <a:latin typeface="Tahoma" pitchFamily="34" charset="0"/>
-                <a:ea typeface="Tahoma" pitchFamily="34" charset="-122"/>
-                <a:cs typeface="Tahoma" pitchFamily="34" charset="-120"/>
+                <a:latin typeface="Sarabun" pitchFamily="34" charset="0"/>
+                <a:ea typeface="Sarabun" pitchFamily="34" charset="-122"/>
+                <a:cs typeface="Sarabun" pitchFamily="34" charset="-120"/>
               </a:rPr>
               <a:t>ฝังใน Word, Excel,</a:t>
             </a:r>
@@ -9042,9 +9042,9 @@
                 <a:solidFill>
                   <a:srgbClr val="2E2420"/>
                 </a:solidFill>
-                <a:latin typeface="Tahoma" pitchFamily="34" charset="0"/>
-                <a:ea typeface="Tahoma" pitchFamily="34" charset="-122"/>
-                <a:cs typeface="Tahoma" pitchFamily="34" charset="-120"/>
+                <a:latin typeface="Sarabun" pitchFamily="34" charset="0"/>
+                <a:ea typeface="Sarabun" pitchFamily="34" charset="-122"/>
+                <a:cs typeface="Sarabun" pitchFamily="34" charset="-120"/>
               </a:rPr>
               <a:t>Teams, Windows</a:t>
             </a:r>
@@ -9103,9 +9103,9 @@
                 <a:solidFill>
                   <a:srgbClr val="4B7A3C"/>
                 </a:solidFill>
-                <a:latin typeface="Tahoma" pitchFamily="34" charset="0"/>
-                <a:ea typeface="Tahoma" pitchFamily="34" charset="-122"/>
-                <a:cs typeface="Tahoma" pitchFamily="34" charset="-120"/>
+                <a:latin typeface="Sarabun" pitchFamily="34" charset="0"/>
+                <a:ea typeface="Sarabun" pitchFamily="34" charset="-122"/>
+                <a:cs typeface="Sarabun" pitchFamily="34" charset="-120"/>
               </a:rPr>
               <a:t>ข่าวดี: </a:t>
             </a:r>
@@ -9117,9 +9117,9 @@
                 <a:solidFill>
                   <a:srgbClr val="2E2420"/>
                 </a:solidFill>
-                <a:latin typeface="Tahoma" pitchFamily="34" charset="0"/>
-                <a:ea typeface="Tahoma" pitchFamily="34" charset="-122"/>
-                <a:cs typeface="Tahoma" pitchFamily="34" charset="-120"/>
+                <a:latin typeface="Sarabun" pitchFamily="34" charset="0"/>
+                <a:ea typeface="Sarabun" pitchFamily="34" charset="-122"/>
+                <a:cs typeface="Sarabun" pitchFamily="34" charset="-120"/>
               </a:rPr>
               <a:t>ทุกค่ายใช้หลักการเดียวกัน — เรียนวิธีสั่งงานครั้งเดียว ใช้ได้ทุกค่าย วันนี้เราเรียนผ่าน Claude</a:t>
             </a:r>
@@ -9228,9 +9228,9 @@
                 <a:solidFill>
                   <a:srgbClr val="AD3A38"/>
                 </a:solidFill>
-                <a:latin typeface="Tahoma" pitchFamily="34" charset="0"/>
-                <a:ea typeface="Tahoma" pitchFamily="34" charset="-122"/>
-                <a:cs typeface="Tahoma" pitchFamily="34" charset="-120"/>
+                <a:latin typeface="Chonburi" pitchFamily="34" charset="0"/>
+                <a:ea typeface="Chonburi" pitchFamily="34" charset="-122"/>
+                <a:cs typeface="Chonburi" pitchFamily="34" charset="-120"/>
               </a:rPr>
               <a:t>การใช้ AI มี 3 ระดับ</a:t>
             </a:r>
@@ -9333,9 +9333,9 @@
                 <a:solidFill>
                   <a:srgbClr val="2E2420"/>
                 </a:solidFill>
-                <a:latin typeface="Tahoma" pitchFamily="34" charset="0"/>
-                <a:ea typeface="Tahoma" pitchFamily="34" charset="-122"/>
-                <a:cs typeface="Tahoma" pitchFamily="34" charset="-120"/>
+                <a:latin typeface="Sarabun" pitchFamily="34" charset="0"/>
+                <a:ea typeface="Sarabun" pitchFamily="34" charset="-122"/>
+                <a:cs typeface="Sarabun" pitchFamily="34" charset="-120"/>
               </a:rPr>
               <a:t>ระดับ 1 — ถาม-ตอบ</a:t>
             </a:r>
@@ -9372,9 +9372,9 @@
                 <a:solidFill>
                   <a:srgbClr val="8A6F57"/>
                 </a:solidFill>
-                <a:latin typeface="Tahoma" pitchFamily="34" charset="0"/>
-                <a:ea typeface="Tahoma" pitchFamily="34" charset="-122"/>
-                <a:cs typeface="Tahoma" pitchFamily="34" charset="-120"/>
+                <a:latin typeface="Sarabun" pitchFamily="34" charset="0"/>
+                <a:ea typeface="Sarabun" pitchFamily="34" charset="-122"/>
+                <a:cs typeface="Sarabun" pitchFamily="34" charset="-120"/>
               </a:rPr>
               <a:t>แชทในเว็บ/แอป: แปล สรุป ร่างข้อความ</a:t>
             </a:r>
@@ -9411,9 +9411,9 @@
                 <a:solidFill>
                   <a:srgbClr val="8A6F57"/>
                 </a:solidFill>
-                <a:latin typeface="Tahoma" pitchFamily="34" charset="0"/>
-                <a:ea typeface="Tahoma" pitchFamily="34" charset="-122"/>
-                <a:cs typeface="Tahoma" pitchFamily="34" charset="-120"/>
+                <a:latin typeface="Sarabun" pitchFamily="34" charset="0"/>
+                <a:ea typeface="Sarabun" pitchFamily="34" charset="-122"/>
+                <a:cs typeface="Sarabun" pitchFamily="34" charset="-120"/>
               </a:rPr>
               <a:t>ทุกคนเริ่มตรงนี้</a:t>
             </a:r>
@@ -9516,9 +9516,9 @@
                 <a:solidFill>
                   <a:srgbClr val="2E2420"/>
                 </a:solidFill>
-                <a:latin typeface="Tahoma" pitchFamily="34" charset="0"/>
-                <a:ea typeface="Tahoma" pitchFamily="34" charset="-122"/>
-                <a:cs typeface="Tahoma" pitchFamily="34" charset="-120"/>
+                <a:latin typeface="Sarabun" pitchFamily="34" charset="0"/>
+                <a:ea typeface="Sarabun" pitchFamily="34" charset="-122"/>
+                <a:cs typeface="Sarabun" pitchFamily="34" charset="-120"/>
               </a:rPr>
               <a:t>ระดับ 2 — ทำงานกับไฟล์ในเครื่องเรา</a:t>
             </a:r>
@@ -9555,9 +9555,9 @@
                 <a:solidFill>
                   <a:srgbClr val="4A2C17"/>
                 </a:solidFill>
-                <a:latin typeface="Tahoma" pitchFamily="34" charset="0"/>
-                <a:ea typeface="Tahoma" pitchFamily="34" charset="-122"/>
-                <a:cs typeface="Tahoma" pitchFamily="34" charset="-120"/>
+                <a:latin typeface="Sarabun" pitchFamily="34" charset="0"/>
+                <a:ea typeface="Sarabun" pitchFamily="34" charset="-122"/>
+                <a:cs typeface="Sarabun" pitchFamily="34" charset="-120"/>
               </a:rPr>
               <a:t>Cowork: อ่านโฟลเดอร์ สรุปอีเมล วิเคราะห์ Excel สร้างรายงาน</a:t>
             </a:r>
@@ -9594,9 +9594,9 @@
                 <a:solidFill>
                   <a:srgbClr val="7A2523"/>
                 </a:solidFill>
-                <a:latin typeface="Tahoma" pitchFamily="34" charset="0"/>
-                <a:ea typeface="Tahoma" pitchFamily="34" charset="-122"/>
-                <a:cs typeface="Tahoma" pitchFamily="34" charset="-120"/>
+                <a:latin typeface="Sarabun" pitchFamily="34" charset="0"/>
+                <a:ea typeface="Sarabun" pitchFamily="34" charset="-122"/>
+                <a:cs typeface="Sarabun" pitchFamily="34" charset="-120"/>
               </a:rPr>
               <a:t>★ วันนี้เน้นตรงนี้</a:t>
             </a:r>
@@ -9699,9 +9699,9 @@
                 <a:solidFill>
                   <a:srgbClr val="FFFFFF"/>
                 </a:solidFill>
-                <a:latin typeface="Tahoma" pitchFamily="34" charset="0"/>
-                <a:ea typeface="Tahoma" pitchFamily="34" charset="-122"/>
-                <a:cs typeface="Tahoma" pitchFamily="34" charset="-120"/>
+                <a:latin typeface="Sarabun" pitchFamily="34" charset="0"/>
+                <a:ea typeface="Sarabun" pitchFamily="34" charset="-122"/>
+                <a:cs typeface="Sarabun" pitchFamily="34" charset="-120"/>
               </a:rPr>
               <a:t>ระดับ 3 — สร้างระบบให้เรา</a:t>
             </a:r>
@@ -9738,9 +9738,9 @@
                 <a:solidFill>
                   <a:srgbClr val="FBEBD0"/>
                 </a:solidFill>
-                <a:latin typeface="Tahoma" pitchFamily="34" charset="0"/>
-                <a:ea typeface="Tahoma" pitchFamily="34" charset="-122"/>
-                <a:cs typeface="Tahoma" pitchFamily="34" charset="-120"/>
+                <a:latin typeface="Sarabun" pitchFamily="34" charset="0"/>
+                <a:ea typeface="Sarabun" pitchFamily="34" charset="-122"/>
+                <a:cs typeface="Sarabun" pitchFamily="34" charset="-120"/>
               </a:rPr>
               <a:t>Claude Code: เขียนโปรแกรม สร้าง Dashboard สร้างเว็บ</a:t>
             </a:r>
@@ -9777,9 +9777,9 @@
                 <a:solidFill>
                   <a:srgbClr val="FFCB64"/>
                 </a:solidFill>
-                <a:latin typeface="Tahoma" pitchFamily="34" charset="0"/>
-                <a:ea typeface="Tahoma" pitchFamily="34" charset="-122"/>
-                <a:cs typeface="Tahoma" pitchFamily="34" charset="-120"/>
+                <a:latin typeface="Sarabun" pitchFamily="34" charset="0"/>
+                <a:ea typeface="Sarabun" pitchFamily="34" charset="-122"/>
+                <a:cs typeface="Sarabun" pitchFamily="34" charset="-120"/>
               </a:rPr>
               <a:t>แถมท้ายคลาส</a:t>
             </a:r>
@@ -9816,9 +9816,9 @@
                 <a:solidFill>
                   <a:srgbClr val="C65E52"/>
                 </a:solidFill>
-                <a:latin typeface="Tahoma" pitchFamily="34" charset="0"/>
-                <a:ea typeface="Tahoma" pitchFamily="34" charset="-122"/>
-                <a:cs typeface="Tahoma" pitchFamily="34" charset="-120"/>
+                <a:latin typeface="Sarabun" pitchFamily="34" charset="0"/>
+                <a:ea typeface="Sarabun" pitchFamily="34" charset="-122"/>
+                <a:cs typeface="Sarabun" pitchFamily="34" charset="-120"/>
               </a:rPr>
               <a:t>ยิ่งขึ้นระดับ ยิ่งทำงานแทนเราได้มากขึ้น — แต่วิธีสั่งเหมือนเดิม: พิมพ์ภาษาคน</a:t>
             </a:r>
@@ -9927,9 +9927,9 @@
                 <a:solidFill>
                   <a:srgbClr val="AD3A38"/>
                 </a:solidFill>
-                <a:latin typeface="Tahoma" pitchFamily="34" charset="0"/>
-                <a:ea typeface="Tahoma" pitchFamily="34" charset="-122"/>
-                <a:cs typeface="Tahoma" pitchFamily="34" charset="-120"/>
+                <a:latin typeface="Chonburi" pitchFamily="34" charset="0"/>
+                <a:ea typeface="Chonburi" pitchFamily="34" charset="-122"/>
+                <a:cs typeface="Chonburi" pitchFamily="34" charset="-120"/>
               </a:rPr>
               <a:t>ข้อควรระวัง 3 ข้อ — ท่องไว้ก่อนเริ่มใช้</a:t>
             </a:r>
@@ -10032,9 +10032,9 @@
                 <a:solidFill>
                   <a:srgbClr val="2E2420"/>
                 </a:solidFill>
-                <a:latin typeface="Tahoma" pitchFamily="34" charset="0"/>
-                <a:ea typeface="Tahoma" pitchFamily="34" charset="-122"/>
-                <a:cs typeface="Tahoma" pitchFamily="34" charset="-120"/>
+                <a:latin typeface="Sarabun" pitchFamily="34" charset="0"/>
+                <a:ea typeface="Sarabun" pitchFamily="34" charset="-122"/>
+                <a:cs typeface="Sarabun" pitchFamily="34" charset="-120"/>
               </a:rPr>
               <a:t>AI ตอบผิดได้อย่างมั่นใจ</a:t>
             </a:r>
@@ -10071,9 +10071,9 @@
                 <a:solidFill>
                   <a:srgbClr val="8A6F57"/>
                 </a:solidFill>
-                <a:latin typeface="Tahoma" pitchFamily="34" charset="0"/>
-                <a:ea typeface="Tahoma" pitchFamily="34" charset="-122"/>
-                <a:cs typeface="Tahoma" pitchFamily="34" charset="-120"/>
+                <a:latin typeface="Sarabun" pitchFamily="34" charset="0"/>
+                <a:ea typeface="Sarabun" pitchFamily="34" charset="-122"/>
+                <a:cs typeface="Sarabun" pitchFamily="34" charset="-120"/>
               </a:rPr>
               <a:t>โดยเฉพาะตัวเลข ชื่อคน วันที่ — ตรวจกับไฟล์จริงก่อนใช้เสมอ</a:t>
             </a:r>
@@ -10176,9 +10176,9 @@
                 <a:solidFill>
                   <a:srgbClr val="2E2420"/>
                 </a:solidFill>
-                <a:latin typeface="Tahoma" pitchFamily="34" charset="0"/>
-                <a:ea typeface="Tahoma" pitchFamily="34" charset="-122"/>
-                <a:cs typeface="Tahoma" pitchFamily="34" charset="-120"/>
+                <a:latin typeface="Sarabun" pitchFamily="34" charset="0"/>
+                <a:ea typeface="Sarabun" pitchFamily="34" charset="-122"/>
+                <a:cs typeface="Sarabun" pitchFamily="34" charset="-120"/>
               </a:rPr>
               <a:t>คิดก่อนอัปโหลด</a:t>
             </a:r>
@@ -10215,9 +10215,9 @@
                 <a:solidFill>
                   <a:srgbClr val="8A6F57"/>
                 </a:solidFill>
-                <a:latin typeface="Tahoma" pitchFamily="34" charset="0"/>
-                <a:ea typeface="Tahoma" pitchFamily="34" charset="-122"/>
-                <a:cs typeface="Tahoma" pitchFamily="34" charset="-120"/>
+                <a:latin typeface="Sarabun" pitchFamily="34" charset="0"/>
+                <a:ea typeface="Sarabun" pitchFamily="34" charset="-122"/>
+                <a:cs typeface="Sarabun" pitchFamily="34" charset="-120"/>
               </a:rPr>
               <a:t>ข้อมูลลับ ข้อมูลส่วนตัวลูกค้า เงินเดือน — ใช้ตามนโยบายที่ทำงาน</a:t>
             </a:r>
@@ -10320,9 +10320,9 @@
                 <a:solidFill>
                   <a:srgbClr val="2E2420"/>
                 </a:solidFill>
-                <a:latin typeface="Tahoma" pitchFamily="34" charset="0"/>
-                <a:ea typeface="Tahoma" pitchFamily="34" charset="-122"/>
-                <a:cs typeface="Tahoma" pitchFamily="34" charset="-120"/>
+                <a:latin typeface="Sarabun" pitchFamily="34" charset="0"/>
+                <a:ea typeface="Sarabun" pitchFamily="34" charset="-122"/>
+                <a:cs typeface="Sarabun" pitchFamily="34" charset="-120"/>
               </a:rPr>
               <a:t>คนตัดสินใจ ไม่ใช่ AI</a:t>
             </a:r>
@@ -10359,9 +10359,9 @@
                 <a:solidFill>
                   <a:srgbClr val="8A6F57"/>
                 </a:solidFill>
-                <a:latin typeface="Tahoma" pitchFamily="34" charset="0"/>
-                <a:ea typeface="Tahoma" pitchFamily="34" charset="-122"/>
-                <a:cs typeface="Tahoma" pitchFamily="34" charset="-120"/>
+                <a:latin typeface="Sarabun" pitchFamily="34" charset="0"/>
+                <a:ea typeface="Sarabun" pitchFamily="34" charset="-122"/>
+                <a:cs typeface="Sarabun" pitchFamily="34" charset="-120"/>
               </a:rPr>
               <a:t>AI เตรียมข้อมูลให้ แต่การตัดสินใจและความรับผิดชอบเป็นของเรา</a:t>
             </a:r>
@@ -10398,9 +10398,9 @@
                 <a:solidFill>
                   <a:srgbClr val="8A6F57"/>
                 </a:solidFill>
-                <a:latin typeface="Tahoma" pitchFamily="34" charset="0"/>
-                <a:ea typeface="Tahoma" pitchFamily="34" charset="-122"/>
-                <a:cs typeface="Tahoma" pitchFamily="34" charset="-120"/>
+                <a:latin typeface="Sarabun" pitchFamily="34" charset="0"/>
+                <a:ea typeface="Sarabun" pitchFamily="34" charset="-122"/>
+                <a:cs typeface="Sarabun" pitchFamily="34" charset="-120"/>
               </a:rPr>
               <a:t>เราจะย้ำ 3 ข้อนี้อีกครั้งตอนเดโม่ — เห็นของจริงแล้วจะเข้าใจว่าทำไมสำคัญ</a:t>
             </a:r>
@@ -10509,9 +10509,9 @@
                 <a:solidFill>
                   <a:srgbClr val="AD3A38"/>
                 </a:solidFill>
-                <a:latin typeface="Tahoma" pitchFamily="34" charset="0"/>
-                <a:ea typeface="Tahoma" pitchFamily="34" charset="-122"/>
-                <a:cs typeface="Tahoma" pitchFamily="34" charset="-120"/>
+                <a:latin typeface="Chonburi" pitchFamily="34" charset="0"/>
+                <a:ea typeface="Chonburi" pitchFamily="34" charset="-122"/>
+                <a:cs typeface="Chonburi" pitchFamily="34" charset="-120"/>
               </a:rPr>
               <a:t>สูตรสั่งงาน 4 ส่วน — ท่าเดียวที่ต้องจำ</a:t>
             </a:r>
@@ -10570,9 +10570,9 @@
                 <a:solidFill>
                   <a:srgbClr val="FFFFFF"/>
                 </a:solidFill>
-                <a:latin typeface="Tahoma" pitchFamily="34" charset="0"/>
-                <a:ea typeface="Tahoma" pitchFamily="34" charset="-122"/>
-                <a:cs typeface="Tahoma" pitchFamily="34" charset="-120"/>
+                <a:latin typeface="Sarabun" pitchFamily="34" charset="0"/>
+                <a:ea typeface="Sarabun" pitchFamily="34" charset="-122"/>
+                <a:cs typeface="Sarabun" pitchFamily="34" charset="-120"/>
               </a:rPr>
               <a:t>บทบาท</a:t>
             </a:r>
@@ -10609,9 +10609,9 @@
                 <a:solidFill>
                   <a:srgbClr val="FFFFFF"/>
                 </a:solidFill>
-                <a:latin typeface="Tahoma" pitchFamily="34" charset="0"/>
-                <a:ea typeface="Tahoma" pitchFamily="34" charset="-122"/>
-                <a:cs typeface="Tahoma" pitchFamily="34" charset="-120"/>
+                <a:latin typeface="Sarabun" pitchFamily="34" charset="0"/>
+                <a:ea typeface="Sarabun" pitchFamily="34" charset="-122"/>
+                <a:cs typeface="Sarabun" pitchFamily="34" charset="-120"/>
               </a:rPr>
               <a:t>คุณเป็นใคร</a:t>
             </a:r>
@@ -10626,9 +10626,9 @@
                 <a:solidFill>
                   <a:srgbClr val="FFFFFF"/>
                 </a:solidFill>
-                <a:latin typeface="Tahoma" pitchFamily="34" charset="0"/>
-                <a:ea typeface="Tahoma" pitchFamily="34" charset="-122"/>
-                <a:cs typeface="Tahoma" pitchFamily="34" charset="-120"/>
+                <a:latin typeface="Sarabun" pitchFamily="34" charset="0"/>
+                <a:ea typeface="Sarabun" pitchFamily="34" charset="-122"/>
+                <a:cs typeface="Sarabun" pitchFamily="34" charset="-120"/>
               </a:rPr>
               <a:t>ให้ AI สวมหมวกไหน</a:t>
             </a:r>
@@ -10665,9 +10665,9 @@
                 <a:solidFill>
                   <a:srgbClr val="8A6F57"/>
                 </a:solidFill>
-                <a:latin typeface="Tahoma" pitchFamily="34" charset="0"/>
-                <a:ea typeface="Tahoma" pitchFamily="34" charset="-122"/>
-                <a:cs typeface="Tahoma" pitchFamily="34" charset="-120"/>
+                <a:latin typeface="Sarabun" pitchFamily="34" charset="0"/>
+                <a:ea typeface="Sarabun" pitchFamily="34" charset="-122"/>
+                <a:cs typeface="Sarabun" pitchFamily="34" charset="-120"/>
               </a:rPr>
               <a:t>+</a:t>
             </a:r>
@@ -10726,9 +10726,9 @@
                 <a:solidFill>
                   <a:srgbClr val="FFFFFF"/>
                 </a:solidFill>
-                <a:latin typeface="Tahoma" pitchFamily="34" charset="0"/>
-                <a:ea typeface="Tahoma" pitchFamily="34" charset="-122"/>
-                <a:cs typeface="Tahoma" pitchFamily="34" charset="-120"/>
+                <a:latin typeface="Sarabun" pitchFamily="34" charset="0"/>
+                <a:ea typeface="Sarabun" pitchFamily="34" charset="-122"/>
+                <a:cs typeface="Sarabun" pitchFamily="34" charset="-120"/>
               </a:rPr>
               <a:t>งาน</a:t>
             </a:r>
@@ -10765,9 +10765,9 @@
                 <a:solidFill>
                   <a:srgbClr val="FFFFFF"/>
                 </a:solidFill>
-                <a:latin typeface="Tahoma" pitchFamily="34" charset="0"/>
-                <a:ea typeface="Tahoma" pitchFamily="34" charset="-122"/>
-                <a:cs typeface="Tahoma" pitchFamily="34" charset="-120"/>
+                <a:latin typeface="Sarabun" pitchFamily="34" charset="0"/>
+                <a:ea typeface="Sarabun" pitchFamily="34" charset="-122"/>
+                <a:cs typeface="Sarabun" pitchFamily="34" charset="-120"/>
               </a:rPr>
               <a:t>ให้ทำอะไร</a:t>
             </a:r>
@@ -10782,9 +10782,9 @@
                 <a:solidFill>
                   <a:srgbClr val="FFFFFF"/>
                 </a:solidFill>
-                <a:latin typeface="Tahoma" pitchFamily="34" charset="0"/>
-                <a:ea typeface="Tahoma" pitchFamily="34" charset="-122"/>
-                <a:cs typeface="Tahoma" pitchFamily="34" charset="-120"/>
+                <a:latin typeface="Sarabun" pitchFamily="34" charset="0"/>
+                <a:ea typeface="Sarabun" pitchFamily="34" charset="-122"/>
+                <a:cs typeface="Sarabun" pitchFamily="34" charset="-120"/>
               </a:rPr>
               <a:t>ชัดๆ 1 อย่าง</a:t>
             </a:r>
@@ -10821,9 +10821,9 @@
                 <a:solidFill>
                   <a:srgbClr val="8A6F57"/>
                 </a:solidFill>
-                <a:latin typeface="Tahoma" pitchFamily="34" charset="0"/>
-                <a:ea typeface="Tahoma" pitchFamily="34" charset="-122"/>
-                <a:cs typeface="Tahoma" pitchFamily="34" charset="-120"/>
+                <a:latin typeface="Sarabun" pitchFamily="34" charset="0"/>
+                <a:ea typeface="Sarabun" pitchFamily="34" charset="-122"/>
+                <a:cs typeface="Sarabun" pitchFamily="34" charset="-120"/>
               </a:rPr>
               <a:t>+</a:t>
             </a:r>
@@ -10882,9 +10882,9 @@
                 <a:solidFill>
                   <a:srgbClr val="FFFFFF"/>
                 </a:solidFill>
-                <a:latin typeface="Tahoma" pitchFamily="34" charset="0"/>
-                <a:ea typeface="Tahoma" pitchFamily="34" charset="-122"/>
-                <a:cs typeface="Tahoma" pitchFamily="34" charset="-120"/>
+                <a:latin typeface="Sarabun" pitchFamily="34" charset="0"/>
+                <a:ea typeface="Sarabun" pitchFamily="34" charset="-122"/>
+                <a:cs typeface="Sarabun" pitchFamily="34" charset="-120"/>
               </a:rPr>
               <a:t>บริบท</a:t>
             </a:r>
@@ -10921,9 +10921,9 @@
                 <a:solidFill>
                   <a:srgbClr val="FFFFFF"/>
                 </a:solidFill>
-                <a:latin typeface="Tahoma" pitchFamily="34" charset="0"/>
-                <a:ea typeface="Tahoma" pitchFamily="34" charset="-122"/>
-                <a:cs typeface="Tahoma" pitchFamily="34" charset="-120"/>
+                <a:latin typeface="Sarabun" pitchFamily="34" charset="0"/>
+                <a:ea typeface="Sarabun" pitchFamily="34" charset="-122"/>
+                <a:cs typeface="Sarabun" pitchFamily="34" charset="-120"/>
               </a:rPr>
               <a:t>ทำไปเพื่ออะไร</a:t>
             </a:r>
@@ -10938,9 +10938,9 @@
                 <a:solidFill>
                   <a:srgbClr val="FFFFFF"/>
                 </a:solidFill>
-                <a:latin typeface="Tahoma" pitchFamily="34" charset="0"/>
-                <a:ea typeface="Tahoma" pitchFamily="34" charset="-122"/>
-                <a:cs typeface="Tahoma" pitchFamily="34" charset="-120"/>
+                <a:latin typeface="Sarabun" pitchFamily="34" charset="0"/>
+                <a:ea typeface="Sarabun" pitchFamily="34" charset="-122"/>
+                <a:cs typeface="Sarabun" pitchFamily="34" charset="-120"/>
               </a:rPr>
               <a:t>ใครจะเอาไปใช้</a:t>
             </a:r>
@@ -10977,9 +10977,9 @@
                 <a:solidFill>
                   <a:srgbClr val="8A6F57"/>
                 </a:solidFill>
-                <a:latin typeface="Tahoma" pitchFamily="34" charset="0"/>
-                <a:ea typeface="Tahoma" pitchFamily="34" charset="-122"/>
-                <a:cs typeface="Tahoma" pitchFamily="34" charset="-120"/>
+                <a:latin typeface="Sarabun" pitchFamily="34" charset="0"/>
+                <a:ea typeface="Sarabun" pitchFamily="34" charset="-122"/>
+                <a:cs typeface="Sarabun" pitchFamily="34" charset="-120"/>
               </a:rPr>
               <a:t>+</a:t>
             </a:r>
@@ -11038,9 +11038,9 @@
                 <a:solidFill>
                   <a:srgbClr val="FFFFFF"/>
                 </a:solidFill>
-                <a:latin typeface="Tahoma" pitchFamily="34" charset="0"/>
-                <a:ea typeface="Tahoma" pitchFamily="34" charset="-122"/>
-                <a:cs typeface="Tahoma" pitchFamily="34" charset="-120"/>
+                <a:latin typeface="Sarabun" pitchFamily="34" charset="0"/>
+                <a:ea typeface="Sarabun" pitchFamily="34" charset="-122"/>
+                <a:cs typeface="Sarabun" pitchFamily="34" charset="-120"/>
               </a:rPr>
               <a:t>รูปแบบ</a:t>
             </a:r>
@@ -11077,9 +11077,9 @@
                 <a:solidFill>
                   <a:srgbClr val="FFFFFF"/>
                 </a:solidFill>
-                <a:latin typeface="Tahoma" pitchFamily="34" charset="0"/>
-                <a:ea typeface="Tahoma" pitchFamily="34" charset="-122"/>
-                <a:cs typeface="Tahoma" pitchFamily="34" charset="-120"/>
+                <a:latin typeface="Sarabun" pitchFamily="34" charset="0"/>
+                <a:ea typeface="Sarabun" pitchFamily="34" charset="-122"/>
+                <a:cs typeface="Sarabun" pitchFamily="34" charset="-120"/>
               </a:rPr>
               <a:t>อยากได้หน้าตาแบบไหน</a:t>
             </a:r>
@@ -11094,9 +11094,9 @@
                 <a:solidFill>
                   <a:srgbClr val="FFFFFF"/>
                 </a:solidFill>
-                <a:latin typeface="Tahoma" pitchFamily="34" charset="0"/>
-                <a:ea typeface="Tahoma" pitchFamily="34" charset="-122"/>
-                <a:cs typeface="Tahoma" pitchFamily="34" charset="-120"/>
+                <a:latin typeface="Sarabun" pitchFamily="34" charset="0"/>
+                <a:ea typeface="Sarabun" pitchFamily="34" charset="-122"/>
+                <a:cs typeface="Sarabun" pitchFamily="34" charset="-120"/>
               </a:rPr>
               <a:t>ตาราง? กี่ข้อ? ภาษาอะไร?</a:t>
             </a:r>
@@ -11155,9 +11155,9 @@
                 <a:solidFill>
                   <a:srgbClr val="FFCB64"/>
                 </a:solidFill>
-                <a:latin typeface="Tahoma" pitchFamily="34" charset="0"/>
-                <a:ea typeface="Tahoma" pitchFamily="34" charset="-122"/>
-                <a:cs typeface="Tahoma" pitchFamily="34" charset="-120"/>
+                <a:latin typeface="Sarabun" pitchFamily="34" charset="0"/>
+                <a:ea typeface="Sarabun" pitchFamily="34" charset="-122"/>
+                <a:cs typeface="Sarabun" pitchFamily="34" charset="-120"/>
               </a:rPr>
               <a:t>“คุณเป็นผู้ช่วยเจ้าของร้าน </a:t>
             </a:r>
@@ -11169,9 +11169,9 @@
                 <a:solidFill>
                   <a:srgbClr val="FFFFFF"/>
                 </a:solidFill>
-                <a:latin typeface="Tahoma" pitchFamily="34" charset="0"/>
-                <a:ea typeface="Tahoma" pitchFamily="34" charset="-122"/>
-                <a:cs typeface="Tahoma" pitchFamily="34" charset="-120"/>
+                <a:latin typeface="Sarabun" pitchFamily="34" charset="0"/>
+                <a:ea typeface="Sarabun" pitchFamily="34" charset="-122"/>
+                <a:cs typeface="Sarabun" pitchFamily="34" charset="-120"/>
               </a:rPr>
               <a:t>ช่วยสรุปอีเมลทั้งหมดในโฟลเดอร์นี้ </a:t>
             </a:r>
@@ -11183,9 +11183,9 @@
                 <a:solidFill>
                   <a:srgbClr val="F3C8B8"/>
                 </a:solidFill>
-                <a:latin typeface="Tahoma" pitchFamily="34" charset="0"/>
-                <a:ea typeface="Tahoma" pitchFamily="34" charset="-122"/>
-                <a:cs typeface="Tahoma" pitchFamily="34" charset="-120"/>
+                <a:latin typeface="Sarabun" pitchFamily="34" charset="0"/>
+                <a:ea typeface="Sarabun" pitchFamily="34" charset="-122"/>
+                <a:cs typeface="Sarabun" pitchFamily="34" charset="-120"/>
               </a:rPr>
               <a:t>ผมเป็นเจ้าของร้านกาแฟ ไม่มีเวลาอ่านทีละฉบับ </a:t>
             </a:r>
@@ -11197,9 +11197,9 @@
                 <a:solidFill>
                   <a:srgbClr val="CFE3B8"/>
                 </a:solidFill>
-                <a:latin typeface="Tahoma" pitchFamily="34" charset="0"/>
-                <a:ea typeface="Tahoma" pitchFamily="34" charset="-122"/>
-                <a:cs typeface="Tahoma" pitchFamily="34" charset="-120"/>
+                <a:latin typeface="Sarabun" pitchFamily="34" charset="0"/>
+                <a:ea typeface="Sarabun" pitchFamily="34" charset="-122"/>
+                <a:cs typeface="Sarabun" pitchFamily="34" charset="-120"/>
               </a:rPr>
               <a:t>ขอเป็นตาราง เรียงตามความด่วน พร้อมบอกว่าต้องทำอะไรต่อ”</a:t>
             </a:r>
@@ -11236,9 +11236,9 @@
                 <a:solidFill>
                   <a:srgbClr val="AD3A38"/>
                 </a:solidFill>
-                <a:latin typeface="Tahoma" pitchFamily="34" charset="0"/>
-                <a:ea typeface="Tahoma" pitchFamily="34" charset="-122"/>
-                <a:cs typeface="Tahoma" pitchFamily="34" charset="-120"/>
+                <a:latin typeface="Sarabun" pitchFamily="34" charset="0"/>
+                <a:ea typeface="Sarabun" pitchFamily="34" charset="-122"/>
+                <a:cs typeface="Sarabun" pitchFamily="34" charset="-120"/>
               </a:rPr>
               <a:t>กฎทอง: </a:t>
             </a:r>
@@ -11250,9 +11250,9 @@
                 <a:solidFill>
                   <a:srgbClr val="2E2420"/>
                 </a:solidFill>
-                <a:latin typeface="Tahoma" pitchFamily="34" charset="0"/>
-                <a:ea typeface="Tahoma" pitchFamily="34" charset="-122"/>
-                <a:cs typeface="Tahoma" pitchFamily="34" charset="-120"/>
+                <a:latin typeface="Sarabun" pitchFamily="34" charset="0"/>
+                <a:ea typeface="Sarabun" pitchFamily="34" charset="-122"/>
+                <a:cs typeface="Sarabun" pitchFamily="34" charset="-120"/>
               </a:rPr>
               <a:t>ผลลัพธ์ไม่ถูกใจ → พิมพ์บอกให้แก้ต่อได้เลย ไม่ต้องเริ่มใหม่  |  คิดไม่ออก → ถามมันว่า “ช่วยอะไรฉันได้บ้าง”</a:t>
             </a:r>
@@ -11381,9 +11381,9 @@
                 <a:solidFill>
                   <a:srgbClr val="C65E52"/>
                 </a:solidFill>
-                <a:latin typeface="Tahoma" pitchFamily="34" charset="0"/>
-                <a:ea typeface="Tahoma" pitchFamily="34" charset="-122"/>
-                <a:cs typeface="Tahoma" pitchFamily="34" charset="-120"/>
+                <a:latin typeface="Chonburi" pitchFamily="34" charset="0"/>
+                <a:ea typeface="Chonburi" pitchFamily="34" charset="-122"/>
+                <a:cs typeface="Chonburi" pitchFamily="34" charset="-120"/>
               </a:rPr>
               <a:t>ช่วงที่ 2</a:t>
             </a:r>
@@ -11420,9 +11420,9 @@
                 <a:solidFill>
                   <a:srgbClr val="AD3A38"/>
                 </a:solidFill>
-                <a:latin typeface="Tahoma" pitchFamily="34" charset="0"/>
-                <a:ea typeface="Tahoma" pitchFamily="34" charset="-122"/>
-                <a:cs typeface="Tahoma" pitchFamily="34" charset="-120"/>
+                <a:latin typeface="Chonburi" pitchFamily="34" charset="0"/>
+                <a:ea typeface="Chonburi" pitchFamily="34" charset="-122"/>
+                <a:cs typeface="Chonburi" pitchFamily="34" charset="-120"/>
               </a:rPr>
               <a:t>เดโม่สด: ร้าน “บ้านกาแฟหอมละมุน”</a:t>
             </a:r>
@@ -11459,9 +11459,9 @@
                 <a:solidFill>
                   <a:srgbClr val="2E2420"/>
                 </a:solidFill>
-                <a:latin typeface="Tahoma" pitchFamily="34" charset="0"/>
-                <a:ea typeface="Tahoma" pitchFamily="34" charset="-122"/>
-                <a:cs typeface="Tahoma" pitchFamily="34" charset="-120"/>
+                <a:latin typeface="Sarabun" pitchFamily="34" charset="0"/>
+                <a:ea typeface="Sarabun" pitchFamily="34" charset="-122"/>
+                <a:cs typeface="Sarabun" pitchFamily="34" charset="-120"/>
               </a:rPr>
               <a:t>สมมติว่าเราเป็นเจ้าของร้าน — เช้านี้มีอีเมลค้าง 4 ฉบับ และไม่รู้เลยว่าเดือนที่แล้วร้านเป็นยังไง</a:t>
             </a:r>
@@ -11542,9 +11542,9 @@
                 <a:solidFill>
                   <a:srgbClr val="2E2420"/>
                 </a:solidFill>
-                <a:latin typeface="Tahoma" pitchFamily="34" charset="0"/>
-                <a:ea typeface="Tahoma" pitchFamily="34" charset="-122"/>
-                <a:cs typeface="Tahoma" pitchFamily="34" charset="-120"/>
+                <a:latin typeface="Sarabun" pitchFamily="34" charset="0"/>
+                <a:ea typeface="Sarabun" pitchFamily="34" charset="-122"/>
+                <a:cs typeface="Sarabun" pitchFamily="34" charset="-120"/>
               </a:rPr>
               <a:t>products.xlsx — เมนู 14 รายการ พร้อมต้นทุน-ราคาขาย</a:t>
             </a:r>
@@ -11625,9 +11625,9 @@
                 <a:solidFill>
                   <a:srgbClr val="2E2420"/>
                 </a:solidFill>
-                <a:latin typeface="Tahoma" pitchFamily="34" charset="0"/>
-                <a:ea typeface="Tahoma" pitchFamily="34" charset="-122"/>
-                <a:cs typeface="Tahoma" pitchFamily="34" charset="-120"/>
+                <a:latin typeface="Sarabun" pitchFamily="34" charset="0"/>
+                <a:ea typeface="Sarabun" pitchFamily="34" charset="-122"/>
+                <a:cs typeface="Sarabun" pitchFamily="34" charset="-120"/>
               </a:rPr>
               <a:t>customers.xlsx — สมาชิกสะสมแต้ม 25 คน</a:t>
             </a:r>
@@ -11708,9 +11708,9 @@
                 <a:solidFill>
                   <a:srgbClr val="2E2420"/>
                 </a:solidFill>
-                <a:latin typeface="Tahoma" pitchFamily="34" charset="0"/>
-                <a:ea typeface="Tahoma" pitchFamily="34" charset="-122"/>
-                <a:cs typeface="Tahoma" pitchFamily="34" charset="-120"/>
+                <a:latin typeface="Sarabun" pitchFamily="34" charset="0"/>
+                <a:ea typeface="Sarabun" pitchFamily="34" charset="-122"/>
+                <a:cs typeface="Sarabun" pitchFamily="34" charset="-120"/>
               </a:rPr>
               <a:t>sales.xlsx — ยอดขาย 1,030 บิล (มิ.ย. – ก.ค.)</a:t>
             </a:r>
@@ -11791,9 +11791,9 @@
                 <a:solidFill>
                   <a:srgbClr val="2E2420"/>
                 </a:solidFill>
-                <a:latin typeface="Tahoma" pitchFamily="34" charset="0"/>
-                <a:ea typeface="Tahoma" pitchFamily="34" charset="-122"/>
-                <a:cs typeface="Tahoma" pitchFamily="34" charset="-120"/>
+                <a:latin typeface="Sarabun" pitchFamily="34" charset="0"/>
+                <a:ea typeface="Sarabun" pitchFamily="34" charset="-122"/>
+                <a:cs typeface="Sarabun" pitchFamily="34" charset="-120"/>
               </a:rPr>
               <a:t>emails/ — อีเมลเข้า 4 ฉบับ รอจัดการ</a:t>
             </a:r>

</xml_diff>